<commit_message>
Update Heart_Failure_Presentation.pptx with Deep Learning integration
Complete presentation refresh with:
- 14 comprehensive slides (expanded from 13)
- Deep Learning (TensorFlow/Keras Neural Network) fully integrated
- All 6 models performance comparison with detailed metrics
- Neural network architecture details slide
- Model selection infographic showing Random Forest as recommended
- Clear justification: highest recall (87.53%) for healthcare deployment
- Professional visualizations and color-coded recommendations
- Ready for course presentation

Key metrics included:
- Random Forest: ROC-AUC 0.9239, Recall 87.53%
- Neural Network: ROC-AUC 0.9212, Recall 84.31%
- Clear recommendation: Random Forest for production due to healthcare priority (higher recall)
</commit_message>
<xml_diff>
--- a/Heart_Failure_Presentation.pptx
+++ b/Heart_Failure_Presentation.pptx
@@ -18,6 +18,7 @@
     <p:sldId id="266" r:id="rId17"/>
     <p:sldId id="267" r:id="rId18"/>
     <p:sldId id="268" r:id="rId19"/>
+    <p:sldId id="269" r:id="rId20"/>
   </p:sldIdLst>
   <p:sldSz cx="9144000" cy="6858000" type="screen4x3"/>
   <p:notesSz cx="6858000" cy="9144000"/>
@@ -3125,11 +3126,6 @@
           <a:solidFill>
             <a:srgbClr val="028090"/>
           </a:solidFill>
-          <a:ln>
-            <a:solidFill>
-              <a:srgbClr val="028090"/>
-            </a:solidFill>
-          </a:ln>
         </p:spPr>
         <p:style>
           <a:lnRef idx="1">
@@ -3161,8 +3157,8 @@
         </p:nvSpPr>
         <p:spPr>
           <a:xfrm>
-            <a:off x="457200" y="1645920"/>
-            <a:ext cx="8229600" cy="1371600"/>
+            <a:off x="914400" y="2011680"/>
+            <a:ext cx="7315200" cy="1371600"/>
           </a:xfrm>
           <a:prstGeom prst="rect">
             <a:avLst/>
@@ -3175,7 +3171,7 @@
           </a:bodyPr>
           <a:lstStyle/>
           <a:p>
-            <a:pPr algn="ctr">
+            <a:pPr>
               <a:defRPr sz="5400" b="1">
                 <a:solidFill>
                   <a:srgbClr val="065A82"/>
@@ -3183,7 +3179,7 @@
               </a:defRPr>
             </a:pPr>
             <a:r>
-              <a:t>Heart Failure Prediction System</a:t>
+              <a:t>Heart Failure Prediction</a:t>
             </a:r>
           </a:p>
         </p:txBody>
@@ -3196,8 +3192,8 @@
         </p:nvSpPr>
         <p:spPr>
           <a:xfrm>
-            <a:off x="457200" y="3017520"/>
-            <a:ext cx="8229600" cy="914400"/>
+            <a:off x="914400" y="3566160"/>
+            <a:ext cx="7315200" cy="1097280"/>
           </a:xfrm>
           <a:prstGeom prst="rect">
             <a:avLst/>
@@ -3205,20 +3201,20 @@
           <a:noFill/>
         </p:spPr>
         <p:txBody>
-          <a:bodyPr wrap="none">
+          <a:bodyPr wrap="square">
             <a:spAutoFit/>
           </a:bodyPr>
           <a:lstStyle/>
           <a:p>
-            <a:pPr algn="ctr">
-              <a:defRPr sz="2800">
+            <a:pPr>
+              <a:defRPr sz="2400">
                 <a:solidFill>
                   <a:srgbClr val="028090"/>
                 </a:solidFill>
               </a:defRPr>
             </a:pPr>
             <a:r>
-              <a:t>Advanced Machine Learning Pipeline with Interactive Web Application</a:t>
+              <a:t>Machine Learning &amp; Deep Learning Analysis</a:t>
             </a:r>
           </a:p>
         </p:txBody>
@@ -3231,8 +3227,8 @@
         </p:nvSpPr>
         <p:spPr>
           <a:xfrm>
-            <a:off x="914400" y="4389120"/>
-            <a:ext cx="7315200" cy="1828800"/>
+            <a:off x="914400" y="5943600"/>
+            <a:ext cx="7315200" cy="731520"/>
           </a:xfrm>
           <a:prstGeom prst="rect">
             <a:avLst/>
@@ -3240,65 +3236,20 @@
           <a:noFill/>
         </p:spPr>
         <p:txBody>
-          <a:bodyPr wrap="square">
+          <a:bodyPr wrap="none">
             <a:spAutoFit/>
           </a:bodyPr>
           <a:lstStyle/>
           <a:p>
-            <a:pPr algn="ctr">
-              <a:defRPr sz="1800">
-                <a:solidFill>
-                  <a:srgbClr val="505050"/>
-                </a:solidFill>
-              </a:defRPr>
-            </a:pPr>
-            <a:r>
-              <a:t>Course: Advanced ML &amp; Data Analytics</a:t>
-            </a:r>
-          </a:p>
-          <a:p>
-            <a:pPr algn="ctr">
-              <a:spcBef>
-                <a:spcPts val="1000"/>
-              </a:spcBef>
-              <a:defRPr sz="1800">
-                <a:solidFill>
-                  <a:srgbClr val="505050"/>
-                </a:solidFill>
-              </a:defRPr>
-            </a:pPr>
-            <a:r>
-              <a:t>Institution: Nexa-land</a:t>
-            </a:r>
-          </a:p>
-          <a:p>
-            <a:pPr algn="ctr">
-              <a:spcBef>
-                <a:spcPts val="1000"/>
-              </a:spcBef>
-              <a:defRPr sz="1800">
-                <a:solidFill>
-                  <a:srgbClr val="505050"/>
-                </a:solidFill>
-              </a:defRPr>
-            </a:pPr>
-            <a:r>
-              <a:t>Instructor: Prof. Hamed Mamani, University of Washington</a:t>
-            </a:r>
-          </a:p>
-          <a:p>
-            <a:pPr algn="ctr">
-              <a:spcBef>
-                <a:spcPts val="1000"/>
-              </a:spcBef>
-              <a:defRPr sz="1800">
-                <a:solidFill>
-                  <a:srgbClr val="505050"/>
-                </a:solidFill>
-              </a:defRPr>
-            </a:pPr>
-            <a:r>
-              <a:t>Author: Mahdi Bakhtiari</a:t>
+            <a:pPr>
+              <a:defRPr sz="1100">
+                <a:solidFill>
+                  <a:srgbClr val="505050"/>
+                </a:solidFill>
+              </a:defRPr>
+            </a:pPr>
+            <a:r>
+              <a:t>Advanced ML &amp; Data Analytics Course | Nexa-land | Prof. Hamed Mamani, University of Washington</a:t>
             </a:r>
           </a:p>
         </p:txBody>
@@ -3404,35 +3355,370 @@
               </a:defRPr>
             </a:pPr>
             <a:r>
-              <a:t>Confusion Matrix &amp; ROC Curve</a:t>
-            </a:r>
-          </a:p>
-        </p:txBody>
-      </p:sp>
-      <p:pic>
-        <p:nvPicPr>
-          <p:cNvPr id="4" name="Picture 3" descr="temp_confusion_roc.png"/>
-          <p:cNvPicPr>
-            <a:picLocks noChangeAspect="1"/>
-          </p:cNvPicPr>
+              <a:t>Deep Learning: Neural Network Details</a:t>
+            </a:r>
+          </a:p>
+        </p:txBody>
+      </p:sp>
+      <p:sp>
+        <p:nvSpPr>
+          <p:cNvPr id="4" name="TextBox 3"/>
+          <p:cNvSpPr txBox="1"/>
           <p:nvPr/>
-        </p:nvPicPr>
-        <p:blipFill>
-          <a:blip r:embed="rId2"/>
-          <a:stretch>
-            <a:fillRect/>
-          </a:stretch>
-        </p:blipFill>
+        </p:nvSpPr>
         <p:spPr>
           <a:xfrm>
             <a:off x="731520" y="1188720"/>
-            <a:ext cx="7680960" cy="3791866"/>
+            <a:ext cx="7680960" cy="5303520"/>
           </a:xfrm>
           <a:prstGeom prst="rect">
             <a:avLst/>
           </a:prstGeom>
+          <a:noFill/>
         </p:spPr>
-      </p:pic>
+        <p:txBody>
+          <a:bodyPr wrap="square">
+            <a:spAutoFit/>
+          </a:bodyPr>
+          <a:lstStyle/>
+          <a:p>
+            <a:pPr>
+              <a:spcBef>
+                <a:spcPts val="100"/>
+              </a:spcBef>
+              <a:defRPr b="1" sz="1200">
+                <a:solidFill>
+                  <a:srgbClr val="028090"/>
+                </a:solidFill>
+              </a:defRPr>
+            </a:pPr>
+            <a:r>
+              <a:t>Network Architecture:</a:t>
+            </a:r>
+          </a:p>
+          <a:p>
+            <a:pPr>
+              <a:spcAft>
+                <a:spcPts val="200"/>
+              </a:spcAft>
+            </a:pPr>
+          </a:p>
+          <a:p>
+            <a:pPr>
+              <a:spcBef>
+                <a:spcPts val="100"/>
+              </a:spcBef>
+              <a:defRPr b="1" sz="1200">
+                <a:solidFill>
+                  <a:srgbClr val="028090"/>
+                </a:solidFill>
+              </a:defRPr>
+            </a:pPr>
+            <a:r>
+              <a:t>Layer Structure:</a:t>
+            </a:r>
+          </a:p>
+          <a:p>
+            <a:pPr>
+              <a:spcBef>
+                <a:spcPts val="100"/>
+              </a:spcBef>
+              <a:defRPr sz="1100">
+                <a:solidFill>
+                  <a:srgbClr val="505050"/>
+                </a:solidFill>
+              </a:defRPr>
+            </a:pPr>
+            <a:r>
+              <a:t>Input</a:t>
+            </a:r>
+          </a:p>
+          <a:p>
+            <a:pPr lvl="1">
+              <a:defRPr sz="1000">
+                <a:solidFill>
+                  <a:srgbClr val="505050"/>
+                </a:solidFill>
+              </a:defRPr>
+            </a:pPr>
+            <a:r>
+              <a:t>11 clinical features</a:t>
+            </a:r>
+          </a:p>
+          <a:p>
+            <a:pPr>
+              <a:spcBef>
+                <a:spcPts val="100"/>
+              </a:spcBef>
+              <a:defRPr sz="1100">
+                <a:solidFill>
+                  <a:srgbClr val="505050"/>
+                </a:solidFill>
+              </a:defRPr>
+            </a:pPr>
+            <a:r>
+              <a:t>Hidden 1</a:t>
+            </a:r>
+          </a:p>
+          <a:p>
+            <a:pPr lvl="1">
+              <a:defRPr sz="1000">
+                <a:solidFill>
+                  <a:srgbClr val="505050"/>
+                </a:solidFill>
+              </a:defRPr>
+            </a:pPr>
+            <a:r>
+              <a:t>128 neurons + ReLU + Dropout(0.3)</a:t>
+            </a:r>
+          </a:p>
+          <a:p>
+            <a:pPr>
+              <a:spcBef>
+                <a:spcPts val="100"/>
+              </a:spcBef>
+              <a:defRPr sz="1100">
+                <a:solidFill>
+                  <a:srgbClr val="505050"/>
+                </a:solidFill>
+              </a:defRPr>
+            </a:pPr>
+            <a:r>
+              <a:t>Hidden 2</a:t>
+            </a:r>
+          </a:p>
+          <a:p>
+            <a:pPr lvl="1">
+              <a:defRPr sz="1000">
+                <a:solidFill>
+                  <a:srgbClr val="505050"/>
+                </a:solidFill>
+              </a:defRPr>
+            </a:pPr>
+            <a:r>
+              <a:t>64 neurons + ReLU + Dropout(0.3)</a:t>
+            </a:r>
+          </a:p>
+          <a:p>
+            <a:pPr>
+              <a:spcBef>
+                <a:spcPts val="100"/>
+              </a:spcBef>
+              <a:defRPr sz="1100">
+                <a:solidFill>
+                  <a:srgbClr val="505050"/>
+                </a:solidFill>
+              </a:defRPr>
+            </a:pPr>
+            <a:r>
+              <a:t>Hidden 3</a:t>
+            </a:r>
+          </a:p>
+          <a:p>
+            <a:pPr lvl="1">
+              <a:defRPr sz="1000">
+                <a:solidFill>
+                  <a:srgbClr val="505050"/>
+                </a:solidFill>
+              </a:defRPr>
+            </a:pPr>
+            <a:r>
+              <a:t>32 neurons + ReLU + Dropout(0.2)</a:t>
+            </a:r>
+          </a:p>
+          <a:p>
+            <a:pPr>
+              <a:spcBef>
+                <a:spcPts val="100"/>
+              </a:spcBef>
+              <a:defRPr sz="1100">
+                <a:solidFill>
+                  <a:srgbClr val="505050"/>
+                </a:solidFill>
+              </a:defRPr>
+            </a:pPr>
+            <a:r>
+              <a:t>Output</a:t>
+            </a:r>
+          </a:p>
+          <a:p>
+            <a:pPr lvl="1">
+              <a:defRPr sz="1000">
+                <a:solidFill>
+                  <a:srgbClr val="505050"/>
+                </a:solidFill>
+              </a:defRPr>
+            </a:pPr>
+            <a:r>
+              <a:t>1 neuron + Sigmoid</a:t>
+            </a:r>
+          </a:p>
+          <a:p>
+            <a:pPr>
+              <a:spcAft>
+                <a:spcPts val="200"/>
+              </a:spcAft>
+            </a:pPr>
+          </a:p>
+          <a:p>
+            <a:pPr>
+              <a:spcBef>
+                <a:spcPts val="100"/>
+              </a:spcBef>
+              <a:defRPr b="1" sz="1200">
+                <a:solidFill>
+                  <a:srgbClr val="028090"/>
+                </a:solidFill>
+              </a:defRPr>
+            </a:pPr>
+            <a:r>
+              <a:t>Training:</a:t>
+            </a:r>
+          </a:p>
+          <a:p>
+            <a:pPr>
+              <a:spcBef>
+                <a:spcPts val="100"/>
+              </a:spcBef>
+              <a:defRPr sz="1100">
+                <a:solidFill>
+                  <a:srgbClr val="505050"/>
+                </a:solidFill>
+              </a:defRPr>
+            </a:pPr>
+            <a:r>
+              <a:t>Optimizer</a:t>
+            </a:r>
+          </a:p>
+          <a:p>
+            <a:pPr lvl="1">
+              <a:defRPr sz="1000">
+                <a:solidFill>
+                  <a:srgbClr val="505050"/>
+                </a:solidFill>
+              </a:defRPr>
+            </a:pPr>
+            <a:r>
+              <a:t>Adam (lr=0.001)</a:t>
+            </a:r>
+          </a:p>
+          <a:p>
+            <a:pPr>
+              <a:spcBef>
+                <a:spcPts val="100"/>
+              </a:spcBef>
+              <a:defRPr sz="1100">
+                <a:solidFill>
+                  <a:srgbClr val="505050"/>
+                </a:solidFill>
+              </a:defRPr>
+            </a:pPr>
+            <a:r>
+              <a:t>Loss</a:t>
+            </a:r>
+          </a:p>
+          <a:p>
+            <a:pPr lvl="1">
+              <a:defRPr sz="1000">
+                <a:solidFill>
+                  <a:srgbClr val="505050"/>
+                </a:solidFill>
+              </a:defRPr>
+            </a:pPr>
+            <a:r>
+              <a:t>Binary Crossentropy</a:t>
+            </a:r>
+          </a:p>
+          <a:p>
+            <a:pPr>
+              <a:spcBef>
+                <a:spcPts val="100"/>
+              </a:spcBef>
+              <a:defRPr sz="1100">
+                <a:solidFill>
+                  <a:srgbClr val="505050"/>
+                </a:solidFill>
+              </a:defRPr>
+            </a:pPr>
+            <a:r>
+              <a:t>Epochs</a:t>
+            </a:r>
+          </a:p>
+          <a:p>
+            <a:pPr lvl="1">
+              <a:defRPr sz="1000">
+                <a:solidFill>
+                  <a:srgbClr val="505050"/>
+                </a:solidFill>
+              </a:defRPr>
+            </a:pPr>
+            <a:r>
+              <a:t>100 with Early Stopping (patience=15)</a:t>
+            </a:r>
+          </a:p>
+          <a:p>
+            <a:pPr>
+              <a:spcBef>
+                <a:spcPts val="100"/>
+              </a:spcBef>
+              <a:defRPr sz="1100">
+                <a:solidFill>
+                  <a:srgbClr val="505050"/>
+                </a:solidFill>
+              </a:defRPr>
+            </a:pPr>
+            <a:r>
+              <a:t>Batch</a:t>
+            </a:r>
+          </a:p>
+          <a:p>
+            <a:pPr lvl="1">
+              <a:defRPr sz="1000">
+                <a:solidFill>
+                  <a:srgbClr val="505050"/>
+                </a:solidFill>
+              </a:defRPr>
+            </a:pPr>
+            <a:r>
+              <a:t>32 | Validation: 20%</a:t>
+            </a:r>
+          </a:p>
+          <a:p>
+            <a:pPr>
+              <a:spcAft>
+                <a:spcPts val="200"/>
+              </a:spcAft>
+            </a:pPr>
+          </a:p>
+          <a:p>
+            <a:pPr>
+              <a:spcBef>
+                <a:spcPts val="100"/>
+              </a:spcBef>
+              <a:defRPr b="1" sz="1200">
+                <a:solidFill>
+                  <a:srgbClr val="028090"/>
+                </a:solidFill>
+              </a:defRPr>
+            </a:pPr>
+            <a:r>
+              <a:t>Performance:</a:t>
+            </a:r>
+          </a:p>
+          <a:p>
+            <a:pPr lvl="1">
+              <a:defRPr sz="1000">
+                <a:solidFill>
+                  <a:srgbClr val="505050"/>
+                </a:solidFill>
+              </a:defRPr>
+            </a:pPr>
+            <a:r>
+              <a:t>ROC-AUC: 0.9212 | Accuracy: 84.24% | Recall: 84.31%</a:t>
+            </a:r>
+          </a:p>
+        </p:txBody>
+      </p:sp>
     </p:spTree>
   </p:cSld>
   <p:clrMapOvr>
@@ -3534,447 +3820,35 @@
               </a:defRPr>
             </a:pPr>
             <a:r>
-              <a:t>Model Selection &amp; Justification</a:t>
-            </a:r>
-          </a:p>
-        </p:txBody>
-      </p:sp>
-      <p:sp>
-        <p:nvSpPr>
-          <p:cNvPr id="4" name="TextBox 3"/>
-          <p:cNvSpPr txBox="1"/>
+              <a:t>Model Selection &amp; Production Recommendation</a:t>
+            </a:r>
+          </a:p>
+        </p:txBody>
+      </p:sp>
+      <p:pic>
+        <p:nvPicPr>
+          <p:cNvPr id="4" name="Picture 3" descr="recommendation.png"/>
+          <p:cNvPicPr>
+            <a:picLocks noChangeAspect="1"/>
+          </p:cNvPicPr>
           <p:nvPr/>
-        </p:nvSpPr>
+        </p:nvPicPr>
+        <p:blipFill>
+          <a:blip r:embed="rId2"/>
+          <a:stretch>
+            <a:fillRect/>
+          </a:stretch>
+        </p:blipFill>
         <p:spPr>
           <a:xfrm>
-            <a:off x="731520" y="1188720"/>
-            <a:ext cx="7680960" cy="5303520"/>
+            <a:off x="91440" y="1097280"/>
+            <a:ext cx="8961120" cy="5337415"/>
           </a:xfrm>
           <a:prstGeom prst="rect">
             <a:avLst/>
           </a:prstGeom>
-          <a:noFill/>
         </p:spPr>
-        <p:txBody>
-          <a:bodyPr wrap="square">
-            <a:spAutoFit/>
-          </a:bodyPr>
-          <a:lstStyle/>
-          <a:p>
-            <a:pPr>
-              <a:spcBef>
-                <a:spcPts val="200"/>
-              </a:spcBef>
-              <a:spcAft>
-                <a:spcPts val="0"/>
-              </a:spcAft>
-              <a:defRPr sz="1400" b="1">
-                <a:solidFill>
-                  <a:srgbClr val="028090"/>
-                </a:solidFill>
-              </a:defRPr>
-            </a:pPr>
-            <a:r>
-              <a:t>Selected Model:</a:t>
-            </a:r>
-          </a:p>
-          <a:p>
-            <a:pPr lvl="1">
-              <a:spcAft>
-                <a:spcPts val="200"/>
-              </a:spcAft>
-              <a:defRPr sz="1100">
-                <a:solidFill>
-                  <a:srgbClr val="505050"/>
-                </a:solidFill>
-              </a:defRPr>
-            </a:pPr>
-            <a:r>
-              <a:t>Random Forest (Regular, not tuned)</a:t>
-            </a:r>
-          </a:p>
-          <a:p>
-            <a:pPr>
-              <a:spcAft>
-                <a:spcPts val="200"/>
-              </a:spcAft>
-            </a:pPr>
-          </a:p>
-          <a:p>
-            <a:pPr>
-              <a:spcBef>
-                <a:spcPts val="200"/>
-              </a:spcBef>
-              <a:spcAft>
-                <a:spcPts val="0"/>
-              </a:spcAft>
-              <a:defRPr sz="1400" b="1">
-                <a:solidFill>
-                  <a:srgbClr val="028090"/>
-                </a:solidFill>
-              </a:defRPr>
-            </a:pPr>
-            <a:r>
-              <a:t>Key Metrics:</a:t>
-            </a:r>
-          </a:p>
-          <a:p>
-            <a:pPr>
-              <a:spcBef>
-                <a:spcPts val="200"/>
-              </a:spcBef>
-              <a:spcAft>
-                <a:spcPts val="0"/>
-              </a:spcAft>
-              <a:defRPr sz="1200">
-                <a:solidFill>
-                  <a:srgbClr val="505050"/>
-                </a:solidFill>
-              </a:defRPr>
-            </a:pPr>
-            <a:r>
-              <a:t>• Cross-Validation ROC-AUC</a:t>
-            </a:r>
-          </a:p>
-          <a:p>
-            <a:pPr lvl="1">
-              <a:spcAft>
-                <a:spcPts val="200"/>
-              </a:spcAft>
-              <a:defRPr sz="1100">
-                <a:solidFill>
-                  <a:srgbClr val="505050"/>
-                </a:solidFill>
-              </a:defRPr>
-            </a:pPr>
-            <a:r>
-              <a:t>0.9242 - Excellent generalization</a:t>
-            </a:r>
-          </a:p>
-          <a:p>
-            <a:pPr>
-              <a:spcBef>
-                <a:spcPts val="200"/>
-              </a:spcBef>
-              <a:spcAft>
-                <a:spcPts val="0"/>
-              </a:spcAft>
-              <a:defRPr sz="1200">
-                <a:solidFill>
-                  <a:srgbClr val="505050"/>
-                </a:solidFill>
-              </a:defRPr>
-            </a:pPr>
-            <a:r>
-              <a:t>• Test Set ROC-AUC</a:t>
-            </a:r>
-          </a:p>
-          <a:p>
-            <a:pPr lvl="1">
-              <a:spcAft>
-                <a:spcPts val="200"/>
-              </a:spcAft>
-              <a:defRPr sz="1100">
-                <a:solidFill>
-                  <a:srgbClr val="505050"/>
-                </a:solidFill>
-              </a:defRPr>
-            </a:pPr>
-            <a:r>
-              <a:t>0.9239 - Perfect consistency with CV</a:t>
-            </a:r>
-          </a:p>
-          <a:p>
-            <a:pPr>
-              <a:spcBef>
-                <a:spcPts val="200"/>
-              </a:spcBef>
-              <a:spcAft>
-                <a:spcPts val="0"/>
-              </a:spcAft>
-              <a:defRPr sz="1200">
-                <a:solidFill>
-                  <a:srgbClr val="505050"/>
-                </a:solidFill>
-              </a:defRPr>
-            </a:pPr>
-            <a:r>
-              <a:t>• CV-Test Gap</a:t>
-            </a:r>
-          </a:p>
-          <a:p>
-            <a:pPr lvl="1">
-              <a:spcAft>
-                <a:spcPts val="200"/>
-              </a:spcAft>
-              <a:defRPr sz="1100">
-                <a:solidFill>
-                  <a:srgbClr val="505050"/>
-                </a:solidFill>
-              </a:defRPr>
-            </a:pPr>
-            <a:r>
-              <a:t>+0.0003 - Exceptional generalization</a:t>
-            </a:r>
-          </a:p>
-          <a:p>
-            <a:pPr>
-              <a:spcBef>
-                <a:spcPts val="200"/>
-              </a:spcBef>
-              <a:spcAft>
-                <a:spcPts val="0"/>
-              </a:spcAft>
-              <a:defRPr sz="1200">
-                <a:solidFill>
-                  <a:srgbClr val="505050"/>
-                </a:solidFill>
-              </a:defRPr>
-            </a:pPr>
-            <a:r>
-              <a:t>• Test Accuracy</a:t>
-            </a:r>
-          </a:p>
-          <a:p>
-            <a:pPr lvl="1">
-              <a:spcAft>
-                <a:spcPts val="200"/>
-              </a:spcAft>
-              <a:defRPr sz="1100">
-                <a:solidFill>
-                  <a:srgbClr val="505050"/>
-                </a:solidFill>
-              </a:defRPr>
-            </a:pPr>
-            <a:r>
-              <a:t>0.8641 - Strong predictive performance</a:t>
-            </a:r>
-          </a:p>
-          <a:p>
-            <a:pPr>
-              <a:spcBef>
-                <a:spcPts val="200"/>
-              </a:spcBef>
-              <a:spcAft>
-                <a:spcPts val="0"/>
-              </a:spcAft>
-              <a:defRPr sz="1200">
-                <a:solidFill>
-                  <a:srgbClr val="505050"/>
-                </a:solidFill>
-              </a:defRPr>
-            </a:pPr>
-            <a:r>
-              <a:t>• Test Recall</a:t>
-            </a:r>
-          </a:p>
-          <a:p>
-            <a:pPr lvl="1">
-              <a:spcAft>
-                <a:spcPts val="200"/>
-              </a:spcAft>
-              <a:defRPr sz="1100">
-                <a:solidFill>
-                  <a:srgbClr val="505050"/>
-                </a:solidFill>
-              </a:defRPr>
-            </a:pPr>
-            <a:r>
-              <a:t>~0.86 - Good at catching disease cases</a:t>
-            </a:r>
-          </a:p>
-          <a:p>
-            <a:pPr>
-              <a:spcAft>
-                <a:spcPts val="200"/>
-              </a:spcAft>
-            </a:pPr>
-          </a:p>
-          <a:p>
-            <a:pPr>
-              <a:spcBef>
-                <a:spcPts val="200"/>
-              </a:spcBef>
-              <a:spcAft>
-                <a:spcPts val="0"/>
-              </a:spcAft>
-              <a:defRPr sz="1300">
-                <a:solidFill>
-                  <a:srgbClr val="505050"/>
-                </a:solidFill>
-              </a:defRPr>
-            </a:pPr>
-            <a:r>
-              <a:t>Why Regular RF over Tuned RF?</a:t>
-            </a:r>
-          </a:p>
-          <a:p>
-            <a:pPr>
-              <a:spcBef>
-                <a:spcPts val="200"/>
-              </a:spcBef>
-              <a:spcAft>
-                <a:spcPts val="0"/>
-              </a:spcAft>
-              <a:defRPr sz="1200" b="1">
-                <a:solidFill>
-                  <a:srgbClr val="1E7E34"/>
-                </a:solidFill>
-              </a:defRPr>
-            </a:pPr>
-            <a:r>
-              <a:t>✓ Better generalization to unseen data</a:t>
-            </a:r>
-          </a:p>
-          <a:p>
-            <a:pPr lvl="1">
-              <a:spcAft>
-                <a:spcPts val="200"/>
-              </a:spcAft>
-              <a:defRPr sz="1100">
-                <a:solidFill>
-                  <a:srgbClr val="505050"/>
-                </a:solidFill>
-              </a:defRPr>
-            </a:pPr>
-            <a:r>
-              <a:t>CV-Test gap of 0.0003 vs 0.0095 in tuned RF</a:t>
-            </a:r>
-          </a:p>
-          <a:p>
-            <a:pPr>
-              <a:spcBef>
-                <a:spcPts val="200"/>
-              </a:spcBef>
-              <a:spcAft>
-                <a:spcPts val="0"/>
-              </a:spcAft>
-              <a:defRPr sz="1200" b="1">
-                <a:solidFill>
-                  <a:srgbClr val="1E7E34"/>
-                </a:solidFill>
-              </a:defRPr>
-            </a:pPr>
-            <a:r>
-              <a:t>✓ Simpler model</a:t>
-            </a:r>
-          </a:p>
-          <a:p>
-            <a:pPr lvl="1">
-              <a:spcAft>
-                <a:spcPts val="200"/>
-              </a:spcAft>
-              <a:defRPr sz="1100">
-                <a:solidFill>
-                  <a:srgbClr val="505050"/>
-                </a:solidFill>
-              </a:defRPr>
-            </a:pPr>
-            <a:r>
-              <a:t>Easier to maintain and explain to healthcare professionals</a:t>
-            </a:r>
-          </a:p>
-          <a:p>
-            <a:pPr>
-              <a:spcBef>
-                <a:spcPts val="200"/>
-              </a:spcBef>
-              <a:spcAft>
-                <a:spcPts val="0"/>
-              </a:spcAft>
-              <a:defRPr sz="1200" b="1">
-                <a:solidFill>
-                  <a:srgbClr val="1E7E34"/>
-                </a:solidFill>
-              </a:defRPr>
-            </a:pPr>
-            <a:r>
-              <a:t>✓ No overfitting risk</a:t>
-            </a:r>
-          </a:p>
-          <a:p>
-            <a:pPr lvl="1">
-              <a:spcAft>
-                <a:spcPts val="200"/>
-              </a:spcAft>
-              <a:defRPr sz="1100">
-                <a:solidFill>
-                  <a:srgbClr val="505050"/>
-                </a:solidFill>
-              </a:defRPr>
-            </a:pPr>
-            <a:r>
-              <a:t>Tuned RF showed signs of overfitting in training data</a:t>
-            </a:r>
-          </a:p>
-          <a:p>
-            <a:pPr>
-              <a:spcBef>
-                <a:spcPts val="200"/>
-              </a:spcBef>
-              <a:spcAft>
-                <a:spcPts val="0"/>
-              </a:spcAft>
-              <a:defRPr sz="1200" b="1">
-                <a:solidFill>
-                  <a:srgbClr val="1E7E34"/>
-                </a:solidFill>
-              </a:defRPr>
-            </a:pPr>
-            <a:r>
-              <a:t>✓ Consistent performance</a:t>
-            </a:r>
-          </a:p>
-          <a:p>
-            <a:pPr lvl="1">
-              <a:spcAft>
-                <a:spcPts val="200"/>
-              </a:spcAft>
-              <a:defRPr sz="1100">
-                <a:solidFill>
-                  <a:srgbClr val="505050"/>
-                </a:solidFill>
-              </a:defRPr>
-            </a:pPr>
-            <a:r>
-              <a:t>Will reliably perform on new patient data</a:t>
-            </a:r>
-          </a:p>
-          <a:p>
-            <a:pPr>
-              <a:spcBef>
-                <a:spcPts val="200"/>
-              </a:spcBef>
-              <a:spcAft>
-                <a:spcPts val="0"/>
-              </a:spcAft>
-              <a:defRPr sz="1200" b="1">
-                <a:solidFill>
-                  <a:srgbClr val="1E7E34"/>
-                </a:solidFill>
-              </a:defRPr>
-            </a:pPr>
-            <a:r>
-              <a:t>✓ Production-ready</a:t>
-            </a:r>
-          </a:p>
-          <a:p>
-            <a:pPr lvl="1">
-              <a:spcAft>
-                <a:spcPts val="200"/>
-              </a:spcAft>
-              <a:defRPr sz="1100">
-                <a:solidFill>
-                  <a:srgbClr val="505050"/>
-                </a:solidFill>
-              </a:defRPr>
-            </a:pPr>
-            <a:r>
-              <a:t>Deployed in Streamlit web application</a:t>
-            </a:r>
-          </a:p>
-        </p:txBody>
-      </p:sp>
+      </p:pic>
     </p:spTree>
   </p:cSld>
   <p:clrMapOvr>
@@ -4076,430 +3950,35 @@
               </a:defRPr>
             </a:pPr>
             <a:r>
-              <a:t>Streamlit Web Application Deployment</a:t>
-            </a:r>
-          </a:p>
-        </p:txBody>
-      </p:sp>
-      <p:sp>
-        <p:nvSpPr>
-          <p:cNvPr id="4" name="TextBox 3"/>
-          <p:cNvSpPr txBox="1"/>
+              <a:t>Confusion Matrix &amp; ROC Curve</a:t>
+            </a:r>
+          </a:p>
+        </p:txBody>
+      </p:sp>
+      <p:pic>
+        <p:nvPicPr>
+          <p:cNvPr id="4" name="Picture 3" descr="roc.png"/>
+          <p:cNvPicPr>
+            <a:picLocks noChangeAspect="1"/>
+          </p:cNvPicPr>
           <p:nvPr/>
-        </p:nvSpPr>
+        </p:nvPicPr>
+        <p:blipFill>
+          <a:blip r:embed="rId2"/>
+          <a:stretch>
+            <a:fillRect/>
+          </a:stretch>
+        </p:blipFill>
         <p:spPr>
           <a:xfrm>
-            <a:off x="731520" y="1188720"/>
-            <a:ext cx="7680960" cy="5303520"/>
+            <a:off x="914400" y="1371600"/>
+            <a:ext cx="7315200" cy="3611301"/>
           </a:xfrm>
           <a:prstGeom prst="rect">
             <a:avLst/>
           </a:prstGeom>
-          <a:noFill/>
         </p:spPr>
-        <p:txBody>
-          <a:bodyPr wrap="square">
-            <a:spAutoFit/>
-          </a:bodyPr>
-          <a:lstStyle/>
-          <a:p>
-            <a:pPr>
-              <a:spcBef>
-                <a:spcPts val="200"/>
-              </a:spcBef>
-              <a:defRPr sz="1400" b="1">
-                <a:solidFill>
-                  <a:srgbClr val="028090"/>
-                </a:solidFill>
-              </a:defRPr>
-            </a:pPr>
-            <a:r>
-              <a:t>Application URL:</a:t>
-            </a:r>
-          </a:p>
-          <a:p>
-            <a:pPr lvl="1">
-              <a:spcAft>
-                <a:spcPts val="200"/>
-              </a:spcAft>
-              <a:defRPr sz="1100">
-                <a:solidFill>
-                  <a:srgbClr val="505050"/>
-                </a:solidFill>
-              </a:defRPr>
-            </a:pPr>
-            <a:r>
-              <a:t>https://heart-failure-prediction-mlcourse2025-2026.streamlit.app/</a:t>
-            </a:r>
-          </a:p>
-          <a:p>
-            <a:pPr>
-              <a:spcAft>
-                <a:spcPts val="200"/>
-              </a:spcAft>
-            </a:pPr>
-          </a:p>
-          <a:p>
-            <a:pPr>
-              <a:spcBef>
-                <a:spcPts val="200"/>
-              </a:spcBef>
-              <a:defRPr sz="1400" b="1">
-                <a:solidFill>
-                  <a:srgbClr val="028090"/>
-                </a:solidFill>
-              </a:defRPr>
-            </a:pPr>
-            <a:r>
-              <a:t>Features:</a:t>
-            </a:r>
-          </a:p>
-          <a:p>
-            <a:pPr>
-              <a:spcBef>
-                <a:spcPts val="200"/>
-              </a:spcBef>
-              <a:defRPr sz="1200">
-                <a:solidFill>
-                  <a:srgbClr val="505050"/>
-                </a:solidFill>
-              </a:defRPr>
-            </a:pPr>
-            <a:r>
-              <a:t>🔮 Make Prediction Tab</a:t>
-            </a:r>
-          </a:p>
-          <a:p>
-            <a:pPr lvl="1">
-              <a:spcAft>
-                <a:spcPts val="200"/>
-              </a:spcAft>
-              <a:defRPr sz="1100">
-                <a:solidFill>
-                  <a:srgbClr val="505050"/>
-                </a:solidFill>
-              </a:defRPr>
-            </a:pPr>
-            <a:r>
-              <a:t>Real-time risk assessment with patient input sliders</a:t>
-            </a:r>
-          </a:p>
-          <a:p>
-            <a:pPr>
-              <a:spcBef>
-                <a:spcPts val="200"/>
-              </a:spcBef>
-              <a:defRPr sz="1200">
-                <a:solidFill>
-                  <a:srgbClr val="505050"/>
-                </a:solidFill>
-              </a:defRPr>
-            </a:pPr>
-            <a:r>
-              <a:t>📊 Patient History Tab</a:t>
-            </a:r>
-          </a:p>
-          <a:p>
-            <a:pPr lvl="1">
-              <a:spcAft>
-                <a:spcPts val="200"/>
-              </a:spcAft>
-              <a:defRPr sz="1100">
-                <a:solidFill>
-                  <a:srgbClr val="505050"/>
-                </a:solidFill>
-              </a:defRPr>
-            </a:pPr>
-            <a:r>
-              <a:t>Track multiple patient predictions and analyze trends</a:t>
-            </a:r>
-          </a:p>
-          <a:p>
-            <a:pPr>
-              <a:spcBef>
-                <a:spcPts val="200"/>
-              </a:spcBef>
-              <a:defRPr sz="1200">
-                <a:solidFill>
-                  <a:srgbClr val="505050"/>
-                </a:solidFill>
-              </a:defRPr>
-            </a:pPr>
-            <a:r>
-              <a:t>📈 Data Insights Tab</a:t>
-            </a:r>
-          </a:p>
-          <a:p>
-            <a:pPr lvl="1">
-              <a:spcAft>
-                <a:spcPts val="200"/>
-              </a:spcAft>
-              <a:defRPr sz="1100">
-                <a:solidFill>
-                  <a:srgbClr val="505050"/>
-                </a:solidFill>
-              </a:defRPr>
-            </a:pPr>
-            <a:r>
-              <a:t>View dataset statistics and visualizations</a:t>
-            </a:r>
-          </a:p>
-          <a:p>
-            <a:pPr>
-              <a:spcBef>
-                <a:spcPts val="200"/>
-              </a:spcBef>
-              <a:defRPr sz="1200">
-                <a:solidFill>
-                  <a:srgbClr val="505050"/>
-                </a:solidFill>
-              </a:defRPr>
-            </a:pPr>
-            <a:r>
-              <a:t>ℹ️ About Project Tab</a:t>
-            </a:r>
-          </a:p>
-          <a:p>
-            <a:pPr lvl="1">
-              <a:spcAft>
-                <a:spcPts val="200"/>
-              </a:spcAft>
-              <a:defRPr sz="1100">
-                <a:solidFill>
-                  <a:srgbClr val="505050"/>
-                </a:solidFill>
-              </a:defRPr>
-            </a:pPr>
-            <a:r>
-              <a:t>Course information and disclaimers</a:t>
-            </a:r>
-          </a:p>
-          <a:p>
-            <a:pPr>
-              <a:spcAft>
-                <a:spcPts val="200"/>
-              </a:spcAft>
-            </a:pPr>
-          </a:p>
-          <a:p>
-            <a:pPr>
-              <a:spcBef>
-                <a:spcPts val="200"/>
-              </a:spcBef>
-              <a:defRPr sz="1400" b="1">
-                <a:solidFill>
-                  <a:srgbClr val="028090"/>
-                </a:solidFill>
-              </a:defRPr>
-            </a:pPr>
-            <a:r>
-              <a:t>Model Explainability:</a:t>
-            </a:r>
-          </a:p>
-          <a:p>
-            <a:pPr>
-              <a:spcBef>
-                <a:spcPts val="200"/>
-              </a:spcBef>
-              <a:defRPr sz="1100">
-                <a:solidFill>
-                  <a:srgbClr val="505050"/>
-                </a:solidFill>
-              </a:defRPr>
-            </a:pPr>
-            <a:r>
-              <a:t>• SHAP Feature Importance</a:t>
-            </a:r>
-          </a:p>
-          <a:p>
-            <a:pPr lvl="1">
-              <a:spcAft>
-                <a:spcPts val="200"/>
-              </a:spcAft>
-              <a:defRPr sz="1100">
-                <a:solidFill>
-                  <a:srgbClr val="505050"/>
-                </a:solidFill>
-              </a:defRPr>
-            </a:pPr>
-            <a:r>
-              <a:t>Shows which features influence each prediction</a:t>
-            </a:r>
-          </a:p>
-          <a:p>
-            <a:pPr>
-              <a:spcBef>
-                <a:spcPts val="200"/>
-              </a:spcBef>
-              <a:defRPr sz="1100">
-                <a:solidFill>
-                  <a:srgbClr val="505050"/>
-                </a:solidFill>
-              </a:defRPr>
-            </a:pPr>
-            <a:r>
-              <a:t>• Risk Percentage Display</a:t>
-            </a:r>
-          </a:p>
-          <a:p>
-            <a:pPr lvl="1">
-              <a:spcAft>
-                <a:spcPts val="200"/>
-              </a:spcAft>
-              <a:defRPr sz="1100">
-                <a:solidFill>
-                  <a:srgbClr val="505050"/>
-                </a:solidFill>
-              </a:defRPr>
-            </a:pPr>
-            <a:r>
-              <a:t>Real-time risk score (0-100%)</a:t>
-            </a:r>
-          </a:p>
-          <a:p>
-            <a:pPr>
-              <a:spcBef>
-                <a:spcPts val="200"/>
-              </a:spcBef>
-              <a:defRPr sz="1100">
-                <a:solidFill>
-                  <a:srgbClr val="505050"/>
-                </a:solidFill>
-              </a:defRPr>
-            </a:pPr>
-            <a:r>
-              <a:t>• Confidence Metrics</a:t>
-            </a:r>
-          </a:p>
-          <a:p>
-            <a:pPr lvl="1">
-              <a:spcAft>
-                <a:spcPts val="200"/>
-              </a:spcAft>
-              <a:defRPr sz="1100">
-                <a:solidFill>
-                  <a:srgbClr val="505050"/>
-                </a:solidFill>
-              </a:defRPr>
-            </a:pPr>
-            <a:r>
-              <a:t>Model confidence for each prediction</a:t>
-            </a:r>
-          </a:p>
-          <a:p>
-            <a:pPr>
-              <a:spcAft>
-                <a:spcPts val="200"/>
-              </a:spcAft>
-            </a:pPr>
-          </a:p>
-          <a:p>
-            <a:pPr>
-              <a:spcBef>
-                <a:spcPts val="200"/>
-              </a:spcBef>
-              <a:defRPr sz="1400" b="1">
-                <a:solidFill>
-                  <a:srgbClr val="028090"/>
-                </a:solidFill>
-              </a:defRPr>
-            </a:pPr>
-            <a:r>
-              <a:t>Data Tracking:</a:t>
-            </a:r>
-          </a:p>
-          <a:p>
-            <a:pPr>
-              <a:spcBef>
-                <a:spcPts val="200"/>
-              </a:spcBef>
-              <a:defRPr sz="1100">
-                <a:solidFill>
-                  <a:srgbClr val="505050"/>
-                </a:solidFill>
-              </a:defRPr>
-            </a:pPr>
-            <a:r>
-              <a:t>• JSON File Storage</a:t>
-            </a:r>
-          </a:p>
-          <a:p>
-            <a:pPr lvl="1">
-              <a:spcAft>
-                <a:spcPts val="200"/>
-              </a:spcAft>
-              <a:defRPr sz="1100">
-                <a:solidFill>
-                  <a:srgbClr val="505050"/>
-                </a:solidFill>
-              </a:defRPr>
-            </a:pPr>
-            <a:r>
-              <a:t>Patient history saved in patient_history.json</a:t>
-            </a:r>
-          </a:p>
-          <a:p>
-            <a:pPr>
-              <a:spcBef>
-                <a:spcPts val="200"/>
-              </a:spcBef>
-              <a:defRPr sz="1100">
-                <a:solidFill>
-                  <a:srgbClr val="505050"/>
-                </a:solidFill>
-              </a:defRPr>
-            </a:pPr>
-            <a:r>
-              <a:t>• Trend Analysis</a:t>
-            </a:r>
-          </a:p>
-          <a:p>
-            <a:pPr lvl="1">
-              <a:spcAft>
-                <a:spcPts val="200"/>
-              </a:spcAft>
-              <a:defRPr sz="1100">
-                <a:solidFill>
-                  <a:srgbClr val="505050"/>
-                </a:solidFill>
-              </a:defRPr>
-            </a:pPr>
-            <a:r>
-              <a:t>Visualize risk trends over multiple visits</a:t>
-            </a:r>
-          </a:p>
-          <a:p>
-            <a:pPr>
-              <a:spcBef>
-                <a:spcPts val="200"/>
-              </a:spcBef>
-              <a:defRPr sz="1100">
-                <a:solidFill>
-                  <a:srgbClr val="505050"/>
-                </a:solidFill>
-              </a:defRPr>
-            </a:pPr>
-            <a:r>
-              <a:t>• Patient Information Display</a:t>
-            </a:r>
-          </a:p>
-          <a:p>
-            <a:pPr lvl="1">
-              <a:spcAft>
-                <a:spcPts val="200"/>
-              </a:spcAft>
-              <a:defRPr sz="1100">
-                <a:solidFill>
-                  <a:srgbClr val="505050"/>
-                </a:solidFill>
-              </a:defRPr>
-            </a:pPr>
-            <a:r>
-              <a:t>Age, sex, and clinical measurements shown</a:t>
-            </a:r>
-          </a:p>
-        </p:txBody>
-      </p:sp>
+      </p:pic>
     </p:spTree>
   </p:cSld>
   <p:clrMapOvr>
@@ -4601,7 +4080,7 @@
               </a:defRPr>
             </a:pPr>
             <a:r>
-              <a:t>Conclusions &amp; Recommendations</a:t>
+              <a:t>Streamlit Web Application Deployment</a:t>
             </a:r>
           </a:p>
         </p:txBody>
@@ -4630,136 +4109,178 @@
           <a:p>
             <a:pPr>
               <a:spcBef>
-                <a:spcPts val="200"/>
-              </a:spcBef>
-              <a:defRPr sz="1400" b="1">
+                <a:spcPts val="100"/>
+              </a:spcBef>
+              <a:defRPr b="1" sz="1300">
                 <a:solidFill>
                   <a:srgbClr val="028090"/>
                 </a:solidFill>
               </a:defRPr>
             </a:pPr>
             <a:r>
-              <a:t>Key Achievements:</a:t>
-            </a:r>
-          </a:p>
-          <a:p>
-            <a:pPr>
-              <a:spcBef>
-                <a:spcPts val="200"/>
+              <a:t>Features:</a:t>
+            </a:r>
+          </a:p>
+          <a:p>
+            <a:pPr>
+              <a:spcBef>
+                <a:spcPts val="100"/>
               </a:spcBef>
               <a:defRPr sz="1200">
                 <a:solidFill>
-                  <a:srgbClr val="1E7E34"/>
-                </a:solidFill>
-              </a:defRPr>
-            </a:pPr>
-            <a:r>
-              <a:t>✓ Built &amp; evaluated 5 machine learning models</a:t>
-            </a:r>
-          </a:p>
-          <a:p>
-            <a:pPr>
-              <a:spcBef>
-                <a:spcPts val="200"/>
+                  <a:srgbClr val="505050"/>
+                </a:solidFill>
+              </a:defRPr>
+            </a:pPr>
+            <a:r>
+              <a:t>1. Real-Time Predictions</a:t>
+            </a:r>
+          </a:p>
+          <a:p>
+            <a:pPr lvl="1">
+              <a:defRPr sz="1000">
+                <a:solidFill>
+                  <a:srgbClr val="505050"/>
+                </a:solidFill>
+              </a:defRPr>
+            </a:pPr>
+            <a:r>
+              <a:t>Instant risk assessment</a:t>
+            </a:r>
+          </a:p>
+          <a:p>
+            <a:pPr>
+              <a:spcBef>
+                <a:spcPts val="100"/>
               </a:spcBef>
               <a:defRPr sz="1200">
                 <a:solidFill>
-                  <a:srgbClr val="1E7E34"/>
-                </a:solidFill>
-              </a:defRPr>
-            </a:pPr>
-            <a:r>
-              <a:t>✓ Achieved 92.39% ROC-AUC on test set</a:t>
-            </a:r>
-          </a:p>
-          <a:p>
-            <a:pPr>
-              <a:spcBef>
-                <a:spcPts val="200"/>
+                  <a:srgbClr val="505050"/>
+                </a:solidFill>
+              </a:defRPr>
+            </a:pPr>
+            <a:r>
+              <a:t>2. Interactive Dashboard</a:t>
+            </a:r>
+          </a:p>
+          <a:p>
+            <a:pPr lvl="1">
+              <a:defRPr sz="1000">
+                <a:solidFill>
+                  <a:srgbClr val="505050"/>
+                </a:solidFill>
+              </a:defRPr>
+            </a:pPr>
+            <a:r>
+              <a:t>Adjustable parameters</a:t>
+            </a:r>
+          </a:p>
+          <a:p>
+            <a:pPr>
+              <a:spcBef>
+                <a:spcPts val="100"/>
               </a:spcBef>
               <a:defRPr sz="1200">
                 <a:solidFill>
-                  <a:srgbClr val="1E7E34"/>
-                </a:solidFill>
-              </a:defRPr>
-            </a:pPr>
-            <a:r>
-              <a:t>✓ Demonstrated exceptional generalization</a:t>
+                  <a:srgbClr val="505050"/>
+                </a:solidFill>
+              </a:defRPr>
+            </a:pPr>
+            <a:r>
+              <a:t>3. Risk Score</a:t>
             </a:r>
           </a:p>
           <a:p>
             <a:pPr lvl="1">
-              <a:spcAft>
-                <a:spcPts val="200"/>
-              </a:spcAft>
-              <a:defRPr sz="1100">
-                <a:solidFill>
-                  <a:srgbClr val="505050"/>
-                </a:solidFill>
-              </a:defRPr>
-            </a:pPr>
-            <a:r>
-              <a:t>CV-Test gap: +0.0003</a:t>
-            </a:r>
-          </a:p>
-          <a:p>
-            <a:pPr>
-              <a:spcBef>
-                <a:spcPts val="200"/>
+              <a:defRPr sz="1000">
+                <a:solidFill>
+                  <a:srgbClr val="505050"/>
+                </a:solidFill>
+              </a:defRPr>
+            </a:pPr>
+            <a:r>
+              <a:t>Probability + classification</a:t>
+            </a:r>
+          </a:p>
+          <a:p>
+            <a:pPr>
+              <a:spcBef>
+                <a:spcPts val="100"/>
               </a:spcBef>
               <a:defRPr sz="1200">
                 <a:solidFill>
-                  <a:srgbClr val="1E7E34"/>
-                </a:solidFill>
-              </a:defRPr>
-            </a:pPr>
-            <a:r>
-              <a:t>✓ Deployed production-ready web application</a:t>
+                  <a:srgbClr val="505050"/>
+                </a:solidFill>
+              </a:defRPr>
+            </a:pPr>
+            <a:r>
+              <a:t>4. Patient History</a:t>
             </a:r>
           </a:p>
           <a:p>
             <a:pPr lvl="1">
-              <a:spcAft>
-                <a:spcPts val="200"/>
-              </a:spcAft>
-              <a:defRPr sz="1100">
-                <a:solidFill>
-                  <a:srgbClr val="505050"/>
-                </a:solidFill>
-              </a:defRPr>
-            </a:pPr>
-            <a:r>
-              <a:t>Live on Streamlit Cloud</a:t>
-            </a:r>
-          </a:p>
-          <a:p>
-            <a:pPr>
-              <a:spcBef>
-                <a:spcPts val="200"/>
+              <a:defRPr sz="1000">
+                <a:solidFill>
+                  <a:srgbClr val="505050"/>
+                </a:solidFill>
+              </a:defRPr>
+            </a:pPr>
+            <a:r>
+              <a:t>Save &amp; view history</a:t>
+            </a:r>
+          </a:p>
+          <a:p>
+            <a:pPr>
+              <a:spcBef>
+                <a:spcPts val="100"/>
               </a:spcBef>
               <a:defRPr sz="1200">
                 <a:solidFill>
-                  <a:srgbClr val="1E7E34"/>
-                </a:solidFill>
-              </a:defRPr>
-            </a:pPr>
-            <a:r>
-              <a:t>✓ Implemented SHAP model explainability</a:t>
+                  <a:srgbClr val="505050"/>
+                </a:solidFill>
+              </a:defRPr>
+            </a:pPr>
+            <a:r>
+              <a:t>5. Trend Analysis</a:t>
             </a:r>
           </a:p>
           <a:p>
             <a:pPr lvl="1">
-              <a:spcAft>
-                <a:spcPts val="200"/>
-              </a:spcAft>
-              <a:defRPr sz="1100">
-                <a:solidFill>
-                  <a:srgbClr val="505050"/>
-                </a:solidFill>
-              </a:defRPr>
-            </a:pPr>
-            <a:r>
-              <a:t>Feature importance analysis</a:t>
+              <a:defRPr sz="1000">
+                <a:solidFill>
+                  <a:srgbClr val="505050"/>
+                </a:solidFill>
+              </a:defRPr>
+            </a:pPr>
+            <a:r>
+              <a:t>Visualize trends</a:t>
+            </a:r>
+          </a:p>
+          <a:p>
+            <a:pPr>
+              <a:spcBef>
+                <a:spcPts val="100"/>
+              </a:spcBef>
+              <a:defRPr sz="1200">
+                <a:solidFill>
+                  <a:srgbClr val="505050"/>
+                </a:solidFill>
+              </a:defRPr>
+            </a:pPr>
+            <a:r>
+              <a:t>6. Feature Importance</a:t>
+            </a:r>
+          </a:p>
+          <a:p>
+            <a:pPr lvl="1">
+              <a:defRPr sz="1000">
+                <a:solidFill>
+                  <a:srgbClr val="505050"/>
+                </a:solidFill>
+              </a:defRPr>
+            </a:pPr>
+            <a:r>
+              <a:t>SHAP analysis</a:t>
             </a:r>
           </a:p>
           <a:p>
@@ -4772,59 +4293,22 @@
           <a:p>
             <a:pPr>
               <a:spcBef>
-                <a:spcPts val="200"/>
-              </a:spcBef>
-              <a:defRPr sz="1500" b="1">
-                <a:solidFill>
-                  <a:srgbClr val="1E7E34"/>
-                </a:solidFill>
-              </a:defRPr>
-            </a:pPr>
-            <a:r>
-              <a:t>Production Status:</a:t>
-            </a:r>
-          </a:p>
-          <a:p>
-            <a:pPr lvl="1">
-              <a:spcAft>
-                <a:spcPts val="200"/>
-              </a:spcAft>
-              <a:defRPr sz="1100">
-                <a:solidFill>
-                  <a:srgbClr val="505050"/>
-                </a:solidFill>
-              </a:defRPr>
-            </a:pPr>
-            <a:r>
-              <a:t>READY FOR DEPLOYMENT</a:t>
-            </a:r>
-          </a:p>
-          <a:p>
-            <a:pPr>
-              <a:spcAft>
-                <a:spcPts val="300"/>
-              </a:spcAft>
-            </a:pPr>
-          </a:p>
-          <a:p>
-            <a:pPr>
-              <a:spcBef>
-                <a:spcPts val="200"/>
-              </a:spcBef>
-              <a:defRPr sz="1400" b="1">
+                <a:spcPts val="100"/>
+              </a:spcBef>
+              <a:defRPr b="1" sz="1300">
                 <a:solidFill>
                   <a:srgbClr val="028090"/>
                 </a:solidFill>
               </a:defRPr>
             </a:pPr>
             <a:r>
-              <a:t>Future Recommendations:</a:t>
-            </a:r>
-          </a:p>
-          <a:p>
-            <a:pPr>
-              <a:spcBef>
-                <a:spcPts val="200"/>
+              <a:t>Technical Stack:</a:t>
+            </a:r>
+          </a:p>
+          <a:p>
+            <a:pPr>
+              <a:spcBef>
+                <a:spcPts val="100"/>
               </a:spcBef>
               <a:defRPr sz="1200">
                 <a:solidFill>
@@ -4833,28 +4317,13 @@
               </a:defRPr>
             </a:pPr>
             <a:r>
-              <a:t>1. Continuous Model Monitoring</a:t>
-            </a:r>
-          </a:p>
-          <a:p>
-            <a:pPr lvl="1">
-              <a:spcAft>
-                <a:spcPts val="200"/>
-              </a:spcAft>
-              <a:defRPr sz="1100">
-                <a:solidFill>
-                  <a:srgbClr val="505050"/>
-                </a:solidFill>
-              </a:defRPr>
-            </a:pPr>
-            <a:r>
-              <a:t>Track prediction accuracy on new patient data</a:t>
-            </a:r>
-          </a:p>
-          <a:p>
-            <a:pPr>
-              <a:spcBef>
-                <a:spcPts val="200"/>
+              <a:t>Framework: Streamlit</a:t>
+            </a:r>
+          </a:p>
+          <a:p>
+            <a:pPr>
+              <a:spcBef>
+                <a:spcPts val="100"/>
               </a:spcBef>
               <a:defRPr sz="1200">
                 <a:solidFill>
@@ -4863,28 +4332,13 @@
               </a:defRPr>
             </a:pPr>
             <a:r>
-              <a:t>2. Periodic Retraining</a:t>
-            </a:r>
-          </a:p>
-          <a:p>
-            <a:pPr lvl="1">
-              <a:spcAft>
-                <a:spcPts val="200"/>
-              </a:spcAft>
-              <a:defRPr sz="1100">
-                <a:solidFill>
-                  <a:srgbClr val="505050"/>
-                </a:solidFill>
-              </a:defRPr>
-            </a:pPr>
-            <a:r>
-              <a:t>Update model quarterly as new patient data arrives</a:t>
-            </a:r>
-          </a:p>
-          <a:p>
-            <a:pPr>
-              <a:spcBef>
-                <a:spcPts val="200"/>
+              <a:t>Model: Random Forest</a:t>
+            </a:r>
+          </a:p>
+          <a:p>
+            <a:pPr>
+              <a:spcBef>
+                <a:spcPts val="100"/>
               </a:spcBef>
               <a:defRPr sz="1200">
                 <a:solidFill>
@@ -4893,28 +4347,13 @@
               </a:defRPr>
             </a:pPr>
             <a:r>
-              <a:t>3. Clinical Validation</a:t>
-            </a:r>
-          </a:p>
-          <a:p>
-            <a:pPr lvl="1">
-              <a:spcAft>
-                <a:spcPts val="200"/>
-              </a:spcAft>
-              <a:defRPr sz="1100">
-                <a:solidFill>
-                  <a:srgbClr val="505050"/>
-                </a:solidFill>
-              </a:defRPr>
-            </a:pPr>
-            <a:r>
-              <a:t>Validate predictions with healthcare professionals</a:t>
-            </a:r>
-          </a:p>
-          <a:p>
-            <a:pPr>
-              <a:spcBef>
-                <a:spcPts val="200"/>
+              <a:t>Storage: JSON</a:t>
+            </a:r>
+          </a:p>
+          <a:p>
+            <a:pPr>
+              <a:spcBef>
+                <a:spcPts val="100"/>
               </a:spcBef>
               <a:defRPr sz="1200">
                 <a:solidFill>
@@ -4923,28 +4362,13 @@
               </a:defRPr>
             </a:pPr>
             <a:r>
-              <a:t>4. Feature Engineering</a:t>
-            </a:r>
-          </a:p>
-          <a:p>
-            <a:pPr lvl="1">
-              <a:spcAft>
-                <a:spcPts val="200"/>
-              </a:spcAft>
-              <a:defRPr sz="1100">
-                <a:solidFill>
-                  <a:srgbClr val="505050"/>
-                </a:solidFill>
-              </a:defRPr>
-            </a:pPr>
-            <a:r>
-              <a:t>Explore new clinical indicators for improved predictions</a:t>
-            </a:r>
-          </a:p>
-          <a:p>
-            <a:pPr>
-              <a:spcBef>
-                <a:spcPts val="200"/>
+              <a:t>Visualization: Plotly, Matplotlib</a:t>
+            </a:r>
+          </a:p>
+          <a:p>
+            <a:pPr>
+              <a:spcBef>
+                <a:spcPts val="100"/>
               </a:spcBef>
               <a:defRPr sz="1200">
                 <a:solidFill>
@@ -4953,28 +4377,13 @@
               </a:defRPr>
             </a:pPr>
             <a:r>
-              <a:t>5. Ensemble Methods</a:t>
-            </a:r>
-          </a:p>
-          <a:p>
-            <a:pPr lvl="1">
-              <a:spcAft>
-                <a:spcPts val="200"/>
-              </a:spcAft>
-              <a:defRPr sz="1100">
-                <a:solidFill>
-                  <a:srgbClr val="505050"/>
-                </a:solidFill>
-              </a:defRPr>
-            </a:pPr>
-            <a:r>
-              <a:t>Consider stacking multiple models for robustness</a:t>
-            </a:r>
-          </a:p>
-          <a:p>
-            <a:pPr>
-              <a:spcBef>
-                <a:spcPts val="200"/>
+              <a:t>Deployment: Streamlit Cloud</a:t>
+            </a:r>
+          </a:p>
+          <a:p>
+            <a:pPr>
+              <a:spcBef>
+                <a:spcPts val="100"/>
               </a:spcBef>
               <a:defRPr sz="1200">
                 <a:solidFill>
@@ -4983,22 +4392,7 @@
               </a:defRPr>
             </a:pPr>
             <a:r>
-              <a:t>6. Mobile Application</a:t>
-            </a:r>
-          </a:p>
-          <a:p>
-            <a:pPr lvl="1">
-              <a:spcAft>
-                <a:spcPts val="200"/>
-              </a:spcAft>
-              <a:defRPr sz="1100">
-                <a:solidFill>
-                  <a:srgbClr val="505050"/>
-                </a:solidFill>
-              </a:defRPr>
-            </a:pPr>
-            <a:r>
-              <a:t>Develop iOS/Android app for wider accessibility</a:t>
+              <a:t>URL: https://heart-disease-predictor...</a:t>
             </a:r>
           </a:p>
         </p:txBody>
@@ -5011,7 +4405,7 @@
 </p:sld>
 </file>
 
-<file path=ppt/slides/slide2.xml><?xml version="1.0" encoding="utf-8"?>
+<file path=ppt/slides/slide14.xml><?xml version="1.0" encoding="utf-8"?>
 <p:sld xmlns:a="http://schemas.openxmlformats.org/drawingml/2006/main" xmlns:p="http://schemas.openxmlformats.org/presentationml/2006/main" xmlns:r="http://schemas.openxmlformats.org/officeDocument/2006/relationships">
   <p:cSld>
     <p:bg>
@@ -5096,15 +4490,15 @@
           </a:bodyPr>
           <a:lstStyle/>
           <a:p>
-            <a:pPr algn="l">
-              <a:defRPr sz="4400" b="1">
+            <a:pPr>
+              <a:defRPr sz="4000" b="1">
                 <a:solidFill>
                   <a:srgbClr val="FFFFFF"/>
                 </a:solidFill>
               </a:defRPr>
             </a:pPr>
             <a:r>
-              <a:t>Table of Contents</a:t>
+              <a:t>Conclusions &amp; Recommendations</a:t>
             </a:r>
           </a:p>
         </p:txBody>
@@ -5117,8 +4511,8 @@
         </p:nvSpPr>
         <p:spPr>
           <a:xfrm>
-            <a:off x="914400" y="1371600"/>
-            <a:ext cx="7315200" cy="5029200"/>
+            <a:off x="731520" y="1188720"/>
+            <a:ext cx="7680960" cy="5303520"/>
           </a:xfrm>
           <a:prstGeom prst="rect">
             <a:avLst/>
@@ -5133,181 +4527,327 @@
           <a:p>
             <a:pPr>
               <a:spcBef>
-                <a:spcPts val="800"/>
-              </a:spcBef>
+                <a:spcPts val="100"/>
+              </a:spcBef>
+              <a:defRPr b="1" sz="1300">
+                <a:solidFill>
+                  <a:srgbClr val="028090"/>
+                </a:solidFill>
+              </a:defRPr>
+            </a:pPr>
+            <a:r>
+              <a:t>Achievements:</a:t>
+            </a:r>
+          </a:p>
+          <a:p>
+            <a:pPr>
+              <a:spcBef>
+                <a:spcPts val="100"/>
+              </a:spcBef>
+              <a:defRPr sz="1200">
+                <a:solidFill>
+                  <a:srgbClr val="505050"/>
+                </a:solidFill>
+              </a:defRPr>
+            </a:pPr>
+            <a:r>
+              <a:t>Built &amp; evaluated 6 ML/DL models</a:t>
+            </a:r>
+          </a:p>
+          <a:p>
+            <a:pPr>
+              <a:spcBef>
+                <a:spcPts val="100"/>
+              </a:spcBef>
+              <a:defRPr sz="1200">
+                <a:solidFill>
+                  <a:srgbClr val="505050"/>
+                </a:solidFill>
+              </a:defRPr>
+            </a:pPr>
+            <a:r>
+              <a:t>Achieved 92.39% ROC-AUC (Random Forest)</a:t>
+            </a:r>
+          </a:p>
+          <a:p>
+            <a:pPr>
+              <a:spcBef>
+                <a:spcPts val="100"/>
+              </a:spcBef>
+              <a:defRPr sz="1200">
+                <a:solidFill>
+                  <a:srgbClr val="505050"/>
+                </a:solidFill>
+              </a:defRPr>
+            </a:pPr>
+            <a:r>
+              <a:t>Neural Network: 92.12% ROC-AUC</a:t>
+            </a:r>
+          </a:p>
+          <a:p>
+            <a:pPr>
+              <a:spcBef>
+                <a:spcPts val="100"/>
+              </a:spcBef>
+              <a:defRPr sz="1200">
+                <a:solidFill>
+                  <a:srgbClr val="505050"/>
+                </a:solidFill>
+              </a:defRPr>
+            </a:pPr>
+            <a:r>
+              <a:t>Exceptional generalization (gap: 0.0003)</a:t>
+            </a:r>
+          </a:p>
+          <a:p>
+            <a:pPr>
+              <a:spcBef>
+                <a:spcPts val="100"/>
+              </a:spcBef>
+              <a:defRPr sz="1200">
+                <a:solidFill>
+                  <a:srgbClr val="505050"/>
+                </a:solidFill>
+              </a:defRPr>
+            </a:pPr>
+            <a:r>
+              <a:t>Deployed production-ready app</a:t>
+            </a:r>
+          </a:p>
+          <a:p>
+            <a:pPr>
+              <a:spcBef>
+                <a:spcPts val="100"/>
+              </a:spcBef>
+              <a:defRPr sz="1200">
+                <a:solidFill>
+                  <a:srgbClr val="505050"/>
+                </a:solidFill>
+              </a:defRPr>
+            </a:pPr>
+            <a:r>
+              <a:t>Implemented SHAP explainability</a:t>
+            </a:r>
+          </a:p>
+          <a:p>
+            <a:pPr>
               <a:spcAft>
-                <a:spcPts val="800"/>
+                <a:spcPts val="300"/>
               </a:spcAft>
-              <a:defRPr sz="1800">
-                <a:solidFill>
-                  <a:srgbClr val="505050"/>
-                </a:solidFill>
-              </a:defRPr>
-            </a:pPr>
-            <a:r>
-              <a:t>1. Project Overview &amp; Problem Statement</a:t>
-            </a:r>
-          </a:p>
-          <a:p>
-            <a:pPr>
-              <a:spcBef>
-                <a:spcPts val="800"/>
-              </a:spcBef>
+            </a:pPr>
+          </a:p>
+          <a:p>
+            <a:pPr>
+              <a:spcBef>
+                <a:spcPts val="100"/>
+              </a:spcBef>
+              <a:defRPr b="1" sz="1400">
+                <a:solidFill>
+                  <a:srgbClr val="1E7E34"/>
+                </a:solidFill>
+              </a:defRPr>
+            </a:pPr>
+            <a:r>
+              <a:t>Recommended: RANDOM FOREST</a:t>
+            </a:r>
+          </a:p>
+          <a:p>
+            <a:pPr>
+              <a:spcBef>
+                <a:spcPts val="100"/>
+              </a:spcBef>
+              <a:defRPr b="1" sz="1400">
+                <a:solidFill>
+                  <a:srgbClr val="1E7E34"/>
+                </a:solidFill>
+              </a:defRPr>
+            </a:pPr>
+            <a:r>
+              <a:t>Status: PRODUCTION READY</a:t>
+            </a:r>
+          </a:p>
+          <a:p>
+            <a:pPr>
               <a:spcAft>
-                <a:spcPts val="800"/>
+                <a:spcPts val="300"/>
               </a:spcAft>
-              <a:defRPr sz="1800">
-                <a:solidFill>
-                  <a:srgbClr val="505050"/>
-                </a:solidFill>
-              </a:defRPr>
-            </a:pPr>
-            <a:r>
-              <a:t>2. Dataset Information &amp; Exploration</a:t>
-            </a:r>
-          </a:p>
-          <a:p>
-            <a:pPr>
-              <a:spcBef>
-                <a:spcPts val="800"/>
-              </a:spcBef>
-              <a:spcAft>
-                <a:spcPts val="800"/>
-              </a:spcAft>
-              <a:defRPr sz="1800">
-                <a:solidFill>
-                  <a:srgbClr val="505050"/>
-                </a:solidFill>
-              </a:defRPr>
-            </a:pPr>
-            <a:r>
-              <a:t>3. Exploratory Data Analysis (EDA)</a:t>
-            </a:r>
-          </a:p>
-          <a:p>
-            <a:pPr>
-              <a:spcBef>
-                <a:spcPts val="800"/>
-              </a:spcBef>
-              <a:spcAft>
-                <a:spcPts val="800"/>
-              </a:spcAft>
-              <a:defRPr sz="1800">
-                <a:solidFill>
-                  <a:srgbClr val="505050"/>
-                </a:solidFill>
-              </a:defRPr>
-            </a:pPr>
-            <a:r>
-              <a:t>4. Machine Learning Models &amp; Preprocessing</a:t>
-            </a:r>
-          </a:p>
-          <a:p>
-            <a:pPr>
-              <a:spcBef>
-                <a:spcPts val="800"/>
-              </a:spcBef>
-              <a:spcAft>
-                <a:spcPts val="800"/>
-              </a:spcAft>
-              <a:defRPr sz="1800">
-                <a:solidFill>
-                  <a:srgbClr val="505050"/>
-                </a:solidFill>
-              </a:defRPr>
-            </a:pPr>
-            <a:r>
-              <a:t>5. Feature Importance Analysis</a:t>
-            </a:r>
-          </a:p>
-          <a:p>
-            <a:pPr>
-              <a:spcBef>
-                <a:spcPts val="800"/>
-              </a:spcBef>
-              <a:spcAft>
-                <a:spcPts val="800"/>
-              </a:spcAft>
-              <a:defRPr sz="1800">
-                <a:solidFill>
-                  <a:srgbClr val="505050"/>
-                </a:solidFill>
-              </a:defRPr>
-            </a:pPr>
-            <a:r>
-              <a:t>6. Model Performance Metrics</a:t>
-            </a:r>
-          </a:p>
-          <a:p>
-            <a:pPr>
-              <a:spcBef>
-                <a:spcPts val="800"/>
-              </a:spcBef>
-              <a:spcAft>
-                <a:spcPts val="800"/>
-              </a:spcAft>
-              <a:defRPr sz="1800">
-                <a:solidFill>
-                  <a:srgbClr val="505050"/>
-                </a:solidFill>
-              </a:defRPr>
-            </a:pPr>
-            <a:r>
-              <a:t>7. Confusion Matrix &amp; ROC Curve</a:t>
-            </a:r>
-          </a:p>
-          <a:p>
-            <a:pPr>
-              <a:spcBef>
-                <a:spcPts val="800"/>
-              </a:spcBef>
-              <a:spcAft>
-                <a:spcPts val="800"/>
-              </a:spcAft>
-              <a:defRPr sz="1800">
-                <a:solidFill>
-                  <a:srgbClr val="505050"/>
-                </a:solidFill>
-              </a:defRPr>
-            </a:pPr>
-            <a:r>
-              <a:t>8. Model Selection &amp; Justification</a:t>
-            </a:r>
-          </a:p>
-          <a:p>
-            <a:pPr>
-              <a:spcBef>
-                <a:spcPts val="800"/>
-              </a:spcBef>
-              <a:spcAft>
-                <a:spcPts val="800"/>
-              </a:spcAft>
-              <a:defRPr sz="1800">
-                <a:solidFill>
-                  <a:srgbClr val="505050"/>
-                </a:solidFill>
-              </a:defRPr>
-            </a:pPr>
-            <a:r>
-              <a:t>9. Streamlit Web Application Deployment</a:t>
-            </a:r>
-          </a:p>
-          <a:p>
-            <a:pPr>
-              <a:spcBef>
-                <a:spcPts val="800"/>
-              </a:spcBef>
-              <a:spcAft>
-                <a:spcPts val="800"/>
-              </a:spcAft>
-              <a:defRPr sz="1800">
-                <a:solidFill>
-                  <a:srgbClr val="505050"/>
-                </a:solidFill>
-              </a:defRPr>
-            </a:pPr>
-            <a:r>
-              <a:t>10. Conclusions &amp; Recommendations</a:t>
+            </a:pPr>
+          </a:p>
+          <a:p>
+            <a:pPr>
+              <a:spcBef>
+                <a:spcPts val="100"/>
+              </a:spcBef>
+              <a:defRPr b="1" sz="1300">
+                <a:solidFill>
+                  <a:srgbClr val="028090"/>
+                </a:solidFill>
+              </a:defRPr>
+            </a:pPr>
+            <a:r>
+              <a:t>Future Work:</a:t>
+            </a:r>
+          </a:p>
+          <a:p>
+            <a:pPr>
+              <a:spcBef>
+                <a:spcPts val="100"/>
+              </a:spcBef>
+              <a:defRPr sz="1200">
+                <a:solidFill>
+                  <a:srgbClr val="505050"/>
+                </a:solidFill>
+              </a:defRPr>
+            </a:pPr>
+            <a:r>
+              <a:t>1. Continuous Monitoring</a:t>
+            </a:r>
+          </a:p>
+          <a:p>
+            <a:pPr lvl="1">
+              <a:defRPr sz="1000">
+                <a:solidFill>
+                  <a:srgbClr val="505050"/>
+                </a:solidFill>
+              </a:defRPr>
+            </a:pPr>
+            <a:r>
+              <a:t>Track new data</a:t>
+            </a:r>
+          </a:p>
+          <a:p>
+            <a:pPr>
+              <a:spcBef>
+                <a:spcPts val="100"/>
+              </a:spcBef>
+              <a:defRPr sz="1200">
+                <a:solidFill>
+                  <a:srgbClr val="505050"/>
+                </a:solidFill>
+              </a:defRPr>
+            </a:pPr>
+            <a:r>
+              <a:t>2. Quarterly Retraining</a:t>
+            </a:r>
+          </a:p>
+          <a:p>
+            <a:pPr lvl="1">
+              <a:defRPr sz="1000">
+                <a:solidFill>
+                  <a:srgbClr val="505050"/>
+                </a:solidFill>
+              </a:defRPr>
+            </a:pPr>
+            <a:r>
+              <a:t>Update model</a:t>
+            </a:r>
+          </a:p>
+          <a:p>
+            <a:pPr>
+              <a:spcBef>
+                <a:spcPts val="100"/>
+              </a:spcBef>
+              <a:defRPr sz="1200">
+                <a:solidFill>
+                  <a:srgbClr val="505050"/>
+                </a:solidFill>
+              </a:defRPr>
+            </a:pPr>
+            <a:r>
+              <a:t>3. Clinical Validation</a:t>
+            </a:r>
+          </a:p>
+          <a:p>
+            <a:pPr lvl="1">
+              <a:defRPr sz="1000">
+                <a:solidFill>
+                  <a:srgbClr val="505050"/>
+                </a:solidFill>
+              </a:defRPr>
+            </a:pPr>
+            <a:r>
+              <a:t>Healthcare testing</a:t>
+            </a:r>
+          </a:p>
+          <a:p>
+            <a:pPr>
+              <a:spcBef>
+                <a:spcPts val="100"/>
+              </a:spcBef>
+              <a:defRPr sz="1200">
+                <a:solidFill>
+                  <a:srgbClr val="505050"/>
+                </a:solidFill>
+              </a:defRPr>
+            </a:pPr>
+            <a:r>
+              <a:t>4. Ensemble Methods</a:t>
+            </a:r>
+          </a:p>
+          <a:p>
+            <a:pPr lvl="1">
+              <a:defRPr sz="1000">
+                <a:solidFill>
+                  <a:srgbClr val="505050"/>
+                </a:solidFill>
+              </a:defRPr>
+            </a:pPr>
+            <a:r>
+              <a:t>RF + NN combination</a:t>
+            </a:r>
+          </a:p>
+          <a:p>
+            <a:pPr>
+              <a:spcBef>
+                <a:spcPts val="100"/>
+              </a:spcBef>
+              <a:defRPr sz="1200">
+                <a:solidFill>
+                  <a:srgbClr val="505050"/>
+                </a:solidFill>
+              </a:defRPr>
+            </a:pPr>
+            <a:r>
+              <a:t>5. Mobile Apps</a:t>
+            </a:r>
+          </a:p>
+          <a:p>
+            <a:pPr lvl="1">
+              <a:defRPr sz="1000">
+                <a:solidFill>
+                  <a:srgbClr val="505050"/>
+                </a:solidFill>
+              </a:defRPr>
+            </a:pPr>
+            <a:r>
+              <a:t>iOS/Android</a:t>
+            </a:r>
+          </a:p>
+          <a:p>
+            <a:pPr>
+              <a:spcBef>
+                <a:spcPts val="100"/>
+              </a:spcBef>
+              <a:defRPr sz="1200">
+                <a:solidFill>
+                  <a:srgbClr val="505050"/>
+                </a:solidFill>
+              </a:defRPr>
+            </a:pPr>
+            <a:r>
+              <a:t>6. Hospital Integration</a:t>
+            </a:r>
+          </a:p>
+          <a:p>
+            <a:pPr lvl="1">
+              <a:defRPr sz="1000">
+                <a:solidFill>
+                  <a:srgbClr val="505050"/>
+                </a:solidFill>
+              </a:defRPr>
+            </a:pPr>
+            <a:r>
+              <a:t>Real-world use</a:t>
             </a:r>
           </a:p>
         </p:txBody>
@@ -5320,7 +4860,7 @@
 </p:sld>
 </file>
 
-<file path=ppt/slides/slide3.xml><?xml version="1.0" encoding="utf-8"?>
+<file path=ppt/slides/slide2.xml><?xml version="1.0" encoding="utf-8"?>
 <p:sld xmlns:a="http://schemas.openxmlformats.org/drawingml/2006/main" xmlns:p="http://schemas.openxmlformats.org/presentationml/2006/main" xmlns:r="http://schemas.openxmlformats.org/officeDocument/2006/relationships">
   <p:cSld>
     <p:bg>
@@ -5413,7 +4953,7 @@
               </a:defRPr>
             </a:pPr>
             <a:r>
-              <a:t>Project Overview &amp; Problem Statement</a:t>
+              <a:t>Table of Contents</a:t>
             </a:r>
           </a:p>
         </p:txBody>
@@ -5426,8 +4966,8 @@
         </p:nvSpPr>
         <p:spPr>
           <a:xfrm>
-            <a:off x="731520" y="1188720"/>
-            <a:ext cx="7680960" cy="5303520"/>
+            <a:off x="1371600" y="1371600"/>
+            <a:ext cx="6400800" cy="5029200"/>
           </a:xfrm>
           <a:prstGeom prst="rect">
             <a:avLst/>
@@ -5441,200 +4981,182 @@
           <a:lstStyle/>
           <a:p>
             <a:pPr>
-              <a:spcBef>
-                <a:spcPts val="600"/>
-              </a:spcBef>
-              <a:spcAft>
-                <a:spcPts val="200"/>
-              </a:spcAft>
-              <a:defRPr sz="1600" b="1">
-                <a:solidFill>
-                  <a:srgbClr val="028090"/>
-                </a:solidFill>
-              </a:defRPr>
-            </a:pPr>
-            <a:r>
-              <a:t>Problem Statement:</a:t>
-            </a:r>
-          </a:p>
-          <a:p>
-            <a:pPr lvl="1">
               <a:spcAft>
                 <a:spcPts val="600"/>
               </a:spcAft>
-              <a:defRPr sz="1400">
-                <a:solidFill>
-                  <a:srgbClr val="505050"/>
-                </a:solidFill>
-              </a:defRPr>
-            </a:pPr>
-            <a:r>
-              <a:t>Develop a machine learning model to predict heart failure risk using clinical data</a:t>
-            </a:r>
-          </a:p>
-          <a:p>
-            <a:pPr>
-              <a:spcBef>
-                <a:spcPts val="600"/>
-              </a:spcBef>
-              <a:spcAft>
-                <a:spcPts val="200"/>
-              </a:spcAft>
-              <a:defRPr sz="1600" b="1">
-                <a:solidFill>
-                  <a:srgbClr val="028090"/>
-                </a:solidFill>
-              </a:defRPr>
-            </a:pPr>
-            <a:r>
-              <a:t>Importance:</a:t>
-            </a:r>
-          </a:p>
-          <a:p>
-            <a:pPr lvl="1">
+              <a:defRPr sz="1600">
+                <a:solidFill>
+                  <a:srgbClr val="505050"/>
+                </a:solidFill>
+              </a:defRPr>
+            </a:pPr>
+            <a:r>
+              <a:t>1. Project Overview &amp; Problem Statement</a:t>
+            </a:r>
+          </a:p>
+          <a:p>
+            <a:pPr>
               <a:spcAft>
                 <a:spcPts val="600"/>
               </a:spcAft>
-              <a:defRPr sz="1400">
-                <a:solidFill>
-                  <a:srgbClr val="505050"/>
-                </a:solidFill>
-              </a:defRPr>
-            </a:pPr>
-            <a:r>
-              <a:t>Early detection of heart disease can save lives and enable preventive care</a:t>
-            </a:r>
-          </a:p>
-          <a:p>
-            <a:pPr>
-              <a:spcBef>
-                <a:spcPts val="600"/>
-              </a:spcBef>
-              <a:spcAft>
-                <a:spcPts val="200"/>
-              </a:spcAft>
-              <a:defRPr sz="1600" b="1">
-                <a:solidFill>
-                  <a:srgbClr val="028090"/>
-                </a:solidFill>
-              </a:defRPr>
-            </a:pPr>
-            <a:r>
-              <a:t>Dataset:</a:t>
-            </a:r>
-          </a:p>
-          <a:p>
-            <a:pPr lvl="1">
+              <a:defRPr sz="1600">
+                <a:solidFill>
+                  <a:srgbClr val="505050"/>
+                </a:solidFill>
+              </a:defRPr>
+            </a:pPr>
+            <a:r>
+              <a:t>2. Dataset Information &amp; Characteristics</a:t>
+            </a:r>
+          </a:p>
+          <a:p>
+            <a:pPr>
               <a:spcAft>
                 <a:spcPts val="600"/>
               </a:spcAft>
-              <a:defRPr sz="1400">
-                <a:solidFill>
-                  <a:srgbClr val="505050"/>
-                </a:solidFill>
-              </a:defRPr>
-            </a:pPr>
-            <a:r>
-              <a:t>918 patient records with 11 clinical features and binary classification target</a:t>
-            </a:r>
-          </a:p>
-          <a:p>
-            <a:pPr>
-              <a:spcBef>
-                <a:spcPts val="600"/>
-              </a:spcBef>
-              <a:spcAft>
-                <a:spcPts val="200"/>
-              </a:spcAft>
-              <a:defRPr sz="1600" b="1">
-                <a:solidFill>
-                  <a:srgbClr val="028090"/>
-                </a:solidFill>
-              </a:defRPr>
-            </a:pPr>
-            <a:r>
-              <a:t>Objective:</a:t>
-            </a:r>
-          </a:p>
-          <a:p>
-            <a:pPr lvl="1">
+              <a:defRPr sz="1600">
+                <a:solidFill>
+                  <a:srgbClr val="505050"/>
+                </a:solidFill>
+              </a:defRPr>
+            </a:pPr>
+            <a:r>
+              <a:t>3. Exploratory Data Analysis - Part 1</a:t>
+            </a:r>
+          </a:p>
+          <a:p>
+            <a:pPr>
               <a:spcAft>
                 <a:spcPts val="600"/>
               </a:spcAft>
-              <a:defRPr sz="1400">
-                <a:solidFill>
-                  <a:srgbClr val="505050"/>
-                </a:solidFill>
-              </a:defRPr>
-            </a:pPr>
-            <a:r>
-              <a:t>Build, evaluate, and deploy a production-ready prediction system</a:t>
-            </a:r>
-          </a:p>
-          <a:p>
-            <a:pPr>
-              <a:spcBef>
-                <a:spcPts val="600"/>
-              </a:spcBef>
-              <a:spcAft>
-                <a:spcPts val="200"/>
-              </a:spcAft>
-              <a:defRPr sz="1600" b="1">
-                <a:solidFill>
-                  <a:srgbClr val="028090"/>
-                </a:solidFill>
-              </a:defRPr>
-            </a:pPr>
-            <a:r>
-              <a:t>Approach:</a:t>
-            </a:r>
-          </a:p>
-          <a:p>
-            <a:pPr lvl="1">
+              <a:defRPr sz="1600">
+                <a:solidFill>
+                  <a:srgbClr val="505050"/>
+                </a:solidFill>
+              </a:defRPr>
+            </a:pPr>
+            <a:r>
+              <a:t>4. Exploratory Data Analysis - Part 2</a:t>
+            </a:r>
+          </a:p>
+          <a:p>
+            <a:pPr>
               <a:spcAft>
                 <a:spcPts val="600"/>
               </a:spcAft>
-              <a:defRPr sz="1400">
-                <a:solidFill>
-                  <a:srgbClr val="505050"/>
-                </a:solidFill>
-              </a:defRPr>
-            </a:pPr>
-            <a:r>
-              <a:t>Compare 5 ML models, optimize hyperparameters, and create interactive web application</a:t>
-            </a:r>
-          </a:p>
-          <a:p>
-            <a:pPr>
-              <a:spcBef>
-                <a:spcPts val="600"/>
-              </a:spcBef>
-              <a:spcAft>
-                <a:spcPts val="200"/>
-              </a:spcAft>
-              <a:defRPr sz="1600" b="1">
-                <a:solidFill>
-                  <a:srgbClr val="028090"/>
-                </a:solidFill>
-              </a:defRPr>
-            </a:pPr>
-            <a:r>
-              <a:t>Deliverable:</a:t>
-            </a:r>
-          </a:p>
-          <a:p>
-            <a:pPr lvl="1">
+              <a:defRPr sz="1600">
+                <a:solidFill>
+                  <a:srgbClr val="505050"/>
+                </a:solidFill>
+              </a:defRPr>
+            </a:pPr>
+            <a:r>
+              <a:t>5. ML &amp; Deep Learning Models Overview</a:t>
+            </a:r>
+          </a:p>
+          <a:p>
+            <a:pPr>
               <a:spcAft>
                 <a:spcPts val="600"/>
               </a:spcAft>
-              <a:defRPr sz="1400">
-                <a:solidFill>
-                  <a:srgbClr val="505050"/>
-                </a:solidFill>
-              </a:defRPr>
-            </a:pPr>
-            <a:r>
-              <a:t>Streamlit web app for real-time risk predictions with SHAP explainability</a:t>
+              <a:defRPr sz="1600">
+                <a:solidFill>
+                  <a:srgbClr val="505050"/>
+                </a:solidFill>
+              </a:defRPr>
+            </a:pPr>
+            <a:r>
+              <a:t>6. Feature Importance Analysis</a:t>
+            </a:r>
+          </a:p>
+          <a:p>
+            <a:pPr>
+              <a:spcAft>
+                <a:spcPts val="600"/>
+              </a:spcAft>
+              <a:defRPr sz="1600">
+                <a:solidFill>
+                  <a:srgbClr val="505050"/>
+                </a:solidFill>
+              </a:defRPr>
+            </a:pPr>
+            <a:r>
+              <a:t>7. All Models Performance Comparison</a:t>
+            </a:r>
+          </a:p>
+          <a:p>
+            <a:pPr>
+              <a:spcAft>
+                <a:spcPts val="600"/>
+              </a:spcAft>
+              <a:defRPr sz="1600">
+                <a:solidFill>
+                  <a:srgbClr val="505050"/>
+                </a:solidFill>
+              </a:defRPr>
+            </a:pPr>
+            <a:r>
+              <a:t>8. Deep Learning: Neural Network Details</a:t>
+            </a:r>
+          </a:p>
+          <a:p>
+            <a:pPr>
+              <a:spcAft>
+                <a:spcPts val="600"/>
+              </a:spcAft>
+              <a:defRPr sz="1600">
+                <a:solidFill>
+                  <a:srgbClr val="505050"/>
+                </a:solidFill>
+              </a:defRPr>
+            </a:pPr>
+            <a:r>
+              <a:t>9. Model Selection &amp; Recommendation</a:t>
+            </a:r>
+          </a:p>
+          <a:p>
+            <a:pPr>
+              <a:spcAft>
+                <a:spcPts val="600"/>
+              </a:spcAft>
+              <a:defRPr sz="1600">
+                <a:solidFill>
+                  <a:srgbClr val="505050"/>
+                </a:solidFill>
+              </a:defRPr>
+            </a:pPr>
+            <a:r>
+              <a:t>10. Confusion Matrix &amp; ROC Curve</a:t>
+            </a:r>
+          </a:p>
+          <a:p>
+            <a:pPr>
+              <a:spcAft>
+                <a:spcPts val="600"/>
+              </a:spcAft>
+              <a:defRPr sz="1600">
+                <a:solidFill>
+                  <a:srgbClr val="505050"/>
+                </a:solidFill>
+              </a:defRPr>
+            </a:pPr>
+            <a:r>
+              <a:t>11. Streamlit Web Application</a:t>
+            </a:r>
+          </a:p>
+          <a:p>
+            <a:pPr>
+              <a:spcAft>
+                <a:spcPts val="600"/>
+              </a:spcAft>
+              <a:defRPr sz="1600">
+                <a:solidFill>
+                  <a:srgbClr val="505050"/>
+                </a:solidFill>
+              </a:defRPr>
+            </a:pPr>
+            <a:r>
+              <a:t>12. Conclusions &amp; Recommendations</a:t>
             </a:r>
           </a:p>
         </p:txBody>
@@ -5647,7 +5169,7 @@
 </p:sld>
 </file>
 
-<file path=ppt/slides/slide4.xml><?xml version="1.0" encoding="utf-8"?>
+<file path=ppt/slides/slide3.xml><?xml version="1.0" encoding="utf-8"?>
 <p:sld xmlns:a="http://schemas.openxmlformats.org/drawingml/2006/main" xmlns:p="http://schemas.openxmlformats.org/presentationml/2006/main" xmlns:r="http://schemas.openxmlformats.org/officeDocument/2006/relationships">
   <p:cSld>
     <p:bg>
@@ -5740,7 +5262,7 @@
               </a:defRPr>
             </a:pPr>
             <a:r>
-              <a:t>Dataset Information &amp; Characteristics</a:t>
+              <a:t>Project Overview &amp; Problem Statement</a:t>
             </a:r>
           </a:p>
         </p:txBody>
@@ -5754,7 +5276,7 @@
         <p:spPr>
           <a:xfrm>
             <a:off x="731520" y="1188720"/>
-            <a:ext cx="4114800" cy="5303520"/>
+            <a:ext cx="7680960" cy="5303520"/>
           </a:xfrm>
           <a:prstGeom prst="rect">
             <a:avLst/>
@@ -5771,35 +5293,118 @@
               <a:spcBef>
                 <a:spcPts val="200"/>
               </a:spcBef>
+              <a:defRPr sz="1400" b="1">
+                <a:solidFill>
+                  <a:srgbClr val="028090"/>
+                </a:solidFill>
+              </a:defRPr>
+            </a:pPr>
+            <a:r>
+              <a:t>Objective:</a:t>
+            </a:r>
+          </a:p>
+          <a:p>
+            <a:pPr lvl="1">
               <a:spcAft>
                 <a:spcPts val="200"/>
               </a:spcAft>
-              <a:defRPr sz="1400" b="0">
-                <a:solidFill>
-                  <a:srgbClr val="505050"/>
-                </a:solidFill>
-              </a:defRPr>
-            </a:pPr>
-            <a:r>
-              <a:t>Total Samples: 918</a:t>
-            </a:r>
+              <a:defRPr sz="1200">
+                <a:solidFill>
+                  <a:srgbClr val="505050"/>
+                </a:solidFill>
+              </a:defRPr>
+            </a:pPr>
+            <a:r>
+              <a:t>Develop ML/DL system to predict heart failure risk</a:t>
+            </a:r>
+          </a:p>
+          <a:p>
+            <a:pPr>
+              <a:spcAft>
+                <a:spcPts val="400"/>
+              </a:spcAft>
+            </a:pPr>
           </a:p>
           <a:p>
             <a:pPr>
               <a:spcBef>
                 <a:spcPts val="200"/>
               </a:spcBef>
+              <a:defRPr sz="1400" b="1">
+                <a:solidFill>
+                  <a:srgbClr val="028090"/>
+                </a:solidFill>
+              </a:defRPr>
+            </a:pPr>
+            <a:r>
+              <a:t>Problem Statement:</a:t>
+            </a:r>
+          </a:p>
+          <a:p>
+            <a:pPr>
+              <a:spcBef>
+                <a:spcPts val="200"/>
+              </a:spcBef>
+              <a:defRPr sz="1300">
+                <a:solidFill>
+                  <a:srgbClr val="505050"/>
+                </a:solidFill>
+              </a:defRPr>
+            </a:pPr>
+            <a:r>
+              <a:t>• Healthcare professionals need data-driven tools</a:t>
+            </a:r>
+          </a:p>
+          <a:p>
+            <a:pPr>
+              <a:spcBef>
+                <a:spcPts val="200"/>
+              </a:spcBef>
+              <a:defRPr sz="1300">
+                <a:solidFill>
+                  <a:srgbClr val="505050"/>
+                </a:solidFill>
+              </a:defRPr>
+            </a:pPr>
+            <a:r>
+              <a:t>• Early prediction can save lives</a:t>
+            </a:r>
+          </a:p>
+          <a:p>
+            <a:pPr>
+              <a:spcBef>
+                <a:spcPts val="200"/>
+              </a:spcBef>
+              <a:defRPr sz="1300">
+                <a:solidFill>
+                  <a:srgbClr val="505050"/>
+                </a:solidFill>
+              </a:defRPr>
+            </a:pPr>
+            <a:r>
+              <a:t>• Comparing traditional ML vs Deep Learning</a:t>
+            </a:r>
+          </a:p>
+          <a:p>
+            <a:pPr>
               <a:spcAft>
+                <a:spcPts val="400"/>
+              </a:spcAft>
+            </a:pPr>
+          </a:p>
+          <a:p>
+            <a:pPr>
+              <a:spcBef>
                 <a:spcPts val="200"/>
-              </a:spcAft>
-              <a:defRPr sz="1400" b="0">
-                <a:solidFill>
-                  <a:srgbClr val="505050"/>
-                </a:solidFill>
-              </a:defRPr>
-            </a:pPr>
-            <a:r>
-              <a:t>Number of Features: 11</a:t>
+              </a:spcBef>
+              <a:defRPr sz="1400" b="1">
+                <a:solidFill>
+                  <a:srgbClr val="028090"/>
+                </a:solidFill>
+              </a:defRPr>
+            </a:pPr>
+            <a:r>
+              <a:t>Our Approach:</a:t>
             </a:r>
           </a:p>
           <a:p>
@@ -5807,17 +5412,29 @@
               <a:spcBef>
                 <a:spcPts val="200"/>
               </a:spcBef>
-              <a:spcAft>
+              <a:defRPr sz="1300">
+                <a:solidFill>
+                  <a:srgbClr val="505050"/>
+                </a:solidFill>
+              </a:defRPr>
+            </a:pPr>
+            <a:r>
+              <a:t>• Evaluate 6 models (5 Traditional + 1 Deep Learning)</a:t>
+            </a:r>
+          </a:p>
+          <a:p>
+            <a:pPr>
+              <a:spcBef>
                 <a:spcPts val="200"/>
-              </a:spcAft>
-              <a:defRPr sz="1400" b="0">
-                <a:solidFill>
-                  <a:srgbClr val="505050"/>
-                </a:solidFill>
-              </a:defRPr>
-            </a:pPr>
-            <a:r>
-              <a:t>Target Variable: HeartDisease</a:t>
+              </a:spcBef>
+              <a:defRPr sz="1300">
+                <a:solidFill>
+                  <a:srgbClr val="505050"/>
+                </a:solidFill>
+              </a:defRPr>
+            </a:pPr>
+            <a:r>
+              <a:t>• Rigorous cross-validation and test evaluation</a:t>
             </a:r>
           </a:p>
           <a:p>
@@ -5825,291 +5442,33 @@
               <a:spcBef>
                 <a:spcPts val="200"/>
               </a:spcBef>
-              <a:spcAft>
+              <a:defRPr sz="1300">
+                <a:solidFill>
+                  <a:srgbClr val="505050"/>
+                </a:solidFill>
+              </a:defRPr>
+            </a:pPr>
+            <a:r>
+              <a:t>• Deploy as interactive web application</a:t>
+            </a:r>
+          </a:p>
+          <a:p>
+            <a:pPr>
+              <a:spcBef>
                 <a:spcPts val="200"/>
-              </a:spcAft>
-              <a:defRPr sz="1400" b="0">
-                <a:solidFill>
-                  <a:srgbClr val="505050"/>
-                </a:solidFill>
-              </a:defRPr>
-            </a:pPr>
-            <a:r>
-              <a:t>Missing Values: 0</a:t>
-            </a:r>
-          </a:p>
-          <a:p>
-            <a:pPr>
-              <a:spcBef>
-                <a:spcPts val="200"/>
-              </a:spcBef>
-              <a:spcAft>
-                <a:spcPts val="200"/>
-              </a:spcAft>
-              <a:defRPr sz="1400" b="0">
-                <a:solidFill>
-                  <a:srgbClr val="505050"/>
-                </a:solidFill>
-              </a:defRPr>
-            </a:pPr>
-            <a:r>
-              <a:t>Duplicate Records: 0</a:t>
-            </a:r>
-          </a:p>
-          <a:p>
-            <a:pPr>
-              <a:spcBef>
-                <a:spcPts val="200"/>
-              </a:spcBef>
-              <a:spcAft>
-                <a:spcPts val="200"/>
-              </a:spcAft>
-              <a:defRPr sz="1400" b="0">
-                <a:solidFill>
-                  <a:srgbClr val="505050"/>
-                </a:solidFill>
-              </a:defRPr>
-            </a:pPr>
-            <a:r>
-              <a:t>Data Quality: 100% Complete</a:t>
-            </a:r>
-          </a:p>
-          <a:p>
-            <a:pPr>
-              <a:spcBef>
-                <a:spcPts val="200"/>
-              </a:spcBef>
-              <a:spcAft>
-                <a:spcPts val="200"/>
-              </a:spcAft>
-              <a:defRPr sz="1400" b="0">
-                <a:solidFill>
-                  <a:srgbClr val="505050"/>
-                </a:solidFill>
-              </a:defRPr>
-            </a:pPr>
-          </a:p>
-          <a:p>
-            <a:pPr>
-              <a:spcBef>
-                <a:spcPts val="200"/>
-              </a:spcBef>
-              <a:spcAft>
-                <a:spcPts val="200"/>
-              </a:spcAft>
-              <a:defRPr sz="1400" b="1">
-                <a:solidFill>
-                  <a:srgbClr val="028090"/>
-                </a:solidFill>
-              </a:defRPr>
-            </a:pPr>
-            <a:r>
-              <a:t>Class Distribution:</a:t>
-            </a:r>
-          </a:p>
-          <a:p>
-            <a:pPr>
-              <a:spcBef>
-                <a:spcPts val="200"/>
-              </a:spcBef>
-              <a:spcAft>
-                <a:spcPts val="200"/>
-              </a:spcAft>
-              <a:defRPr sz="1300" b="0">
-                <a:solidFill>
-                  <a:srgbClr val="505050"/>
-                </a:solidFill>
-              </a:defRPr>
-            </a:pPr>
-            <a:r>
-              <a:t>  No Disease: 410 (44.7%)</a:t>
-            </a:r>
-          </a:p>
-          <a:p>
-            <a:pPr>
-              <a:spcBef>
-                <a:spcPts val="200"/>
-              </a:spcBef>
-              <a:spcAft>
-                <a:spcPts val="200"/>
-              </a:spcAft>
-              <a:defRPr sz="1300" b="0">
-                <a:solidFill>
-                  <a:srgbClr val="505050"/>
-                </a:solidFill>
-              </a:defRPr>
-            </a:pPr>
-            <a:r>
-              <a:t>  Heart Failure: 508 (55.3%)</a:t>
-            </a:r>
-          </a:p>
-          <a:p>
-            <a:pPr>
-              <a:spcBef>
-                <a:spcPts val="200"/>
-              </a:spcBef>
-              <a:spcAft>
-                <a:spcPts val="200"/>
-              </a:spcAft>
-              <a:defRPr sz="1400" b="0">
-                <a:solidFill>
-                  <a:srgbClr val="505050"/>
-                </a:solidFill>
-              </a:defRPr>
-            </a:pPr>
-          </a:p>
-          <a:p>
-            <a:pPr>
-              <a:spcBef>
-                <a:spcPts val="200"/>
-              </a:spcBef>
-              <a:spcAft>
-                <a:spcPts val="200"/>
-              </a:spcAft>
-              <a:defRPr sz="1400" b="1">
-                <a:solidFill>
-                  <a:srgbClr val="028090"/>
-                </a:solidFill>
-              </a:defRPr>
-            </a:pPr>
-            <a:r>
-              <a:t>Features:</a:t>
-            </a:r>
-          </a:p>
-          <a:p>
-            <a:pPr>
-              <a:spcBef>
-                <a:spcPts val="200"/>
-              </a:spcBef>
-              <a:spcAft>
-                <a:spcPts val="200"/>
-              </a:spcAft>
-              <a:defRPr sz="1300" b="0">
-                <a:solidFill>
-                  <a:srgbClr val="505050"/>
-                </a:solidFill>
-              </a:defRPr>
-            </a:pPr>
-            <a:r>
-              <a:t>  - Demographics: Age, Sex</a:t>
-            </a:r>
-          </a:p>
-          <a:p>
-            <a:pPr>
-              <a:spcBef>
-                <a:spcPts val="200"/>
-              </a:spcBef>
-              <a:spcAft>
-                <a:spcPts val="200"/>
-              </a:spcAft>
-              <a:defRPr sz="1300" b="0">
-                <a:solidFill>
-                  <a:srgbClr val="505050"/>
-                </a:solidFill>
-              </a:defRPr>
-            </a:pPr>
-            <a:r>
-              <a:t>  - Clinical: ChestPainType</a:t>
-            </a:r>
-          </a:p>
-          <a:p>
-            <a:pPr>
-              <a:spcBef>
-                <a:spcPts val="200"/>
-              </a:spcBef>
-              <a:spcAft>
-                <a:spcPts val="200"/>
-              </a:spcAft>
-              <a:defRPr sz="1300" b="0">
-                <a:solidFill>
-                  <a:srgbClr val="505050"/>
-                </a:solidFill>
-              </a:defRPr>
-            </a:pPr>
-            <a:r>
-              <a:t>  - Measurements: RestingBP, MaxHR</a:t>
-            </a:r>
-          </a:p>
-          <a:p>
-            <a:pPr>
-              <a:spcBef>
-                <a:spcPts val="200"/>
-              </a:spcBef>
-              <a:spcAft>
-                <a:spcPts val="200"/>
-              </a:spcAft>
-              <a:defRPr sz="1300" b="0">
-                <a:solidFill>
-                  <a:srgbClr val="505050"/>
-                </a:solidFill>
-              </a:defRPr>
-            </a:pPr>
-            <a:r>
-              <a:t>  - Blood: Cholesterol, FastingBS</a:t>
-            </a:r>
-          </a:p>
-          <a:p>
-            <a:pPr>
-              <a:spcBef>
-                <a:spcPts val="200"/>
-              </a:spcBef>
-              <a:spcAft>
-                <a:spcPts val="200"/>
-              </a:spcAft>
-              <a:defRPr sz="1300" b="0">
-                <a:solidFill>
-                  <a:srgbClr val="505050"/>
-                </a:solidFill>
-              </a:defRPr>
-            </a:pPr>
-            <a:r>
-              <a:t>  - ECG: RestingECG, ST_Slope</a:t>
-            </a:r>
-          </a:p>
-          <a:p>
-            <a:pPr>
-              <a:spcBef>
-                <a:spcPts val="200"/>
-              </a:spcBef>
-              <a:spcAft>
-                <a:spcPts val="200"/>
-              </a:spcAft>
-              <a:defRPr sz="1300" b="0">
-                <a:solidFill>
-                  <a:srgbClr val="505050"/>
-                </a:solidFill>
-              </a:defRPr>
-            </a:pPr>
-            <a:r>
-              <a:t>  - Exercise: ExerciseAngina, Oldpeak</a:t>
-            </a:r>
-          </a:p>
-        </p:txBody>
-      </p:sp>
-      <p:pic>
-        <p:nvPicPr>
-          <p:cNvPr id="5" name="Picture 4" descr="temp_class_dist.png"/>
-          <p:cNvPicPr>
-            <a:picLocks noChangeAspect="1"/>
-          </p:cNvPicPr>
-          <p:nvPr/>
-        </p:nvPicPr>
-        <p:blipFill>
-          <a:blip r:embed="rId2"/>
-          <a:stretch>
-            <a:fillRect/>
-          </a:stretch>
-        </p:blipFill>
-        <p:spPr>
-          <a:xfrm>
-            <a:off x="5029200" y="2286000"/>
-            <a:ext cx="3657600" cy="2905570"/>
-          </a:xfrm>
-          <a:prstGeom prst="rect">
-            <a:avLst/>
-          </a:prstGeom>
-        </p:spPr>
-      </p:pic>
+              </a:spcBef>
+              <a:defRPr sz="1300">
+                <a:solidFill>
+                  <a:srgbClr val="505050"/>
+                </a:solidFill>
+              </a:defRPr>
+            </a:pPr>
+            <a:r>
+              <a:t>• Focus on healthcare: maximize Recall</a:t>
+            </a:r>
+          </a:p>
+        </p:txBody>
+      </p:sp>
     </p:spTree>
   </p:cSld>
   <p:clrMapOvr>
@@ -6118,7 +5477,7 @@
 </p:sld>
 </file>
 
-<file path=ppt/slides/slide5.xml><?xml version="1.0" encoding="utf-8"?>
+<file path=ppt/slides/slide4.xml><?xml version="1.0" encoding="utf-8"?>
 <p:sld xmlns:a="http://schemas.openxmlformats.org/drawingml/2006/main" xmlns:p="http://schemas.openxmlformats.org/presentationml/2006/main" xmlns:r="http://schemas.openxmlformats.org/officeDocument/2006/relationships">
   <p:cSld>
     <p:bg>
@@ -6211,14 +5570,344 @@
               </a:defRPr>
             </a:pPr>
             <a:r>
-              <a:t>Exploratory Data Analysis (EDA) - Part 1</a:t>
+              <a:t>Dataset Information &amp; Characteristics</a:t>
+            </a:r>
+          </a:p>
+        </p:txBody>
+      </p:sp>
+      <p:sp>
+        <p:nvSpPr>
+          <p:cNvPr id="4" name="TextBox 3"/>
+          <p:cNvSpPr txBox="1"/>
+          <p:nvPr/>
+        </p:nvSpPr>
+        <p:spPr>
+          <a:xfrm>
+            <a:off x="731520" y="1188720"/>
+            <a:ext cx="7680960" cy="5303520"/>
+          </a:xfrm>
+          <a:prstGeom prst="rect">
+            <a:avLst/>
+          </a:prstGeom>
+          <a:noFill/>
+        </p:spPr>
+        <p:txBody>
+          <a:bodyPr wrap="square">
+            <a:spAutoFit/>
+          </a:bodyPr>
+          <a:lstStyle/>
+          <a:p>
+            <a:pPr>
+              <a:spcBef>
+                <a:spcPts val="100"/>
+              </a:spcBef>
+              <a:defRPr sz="1200">
+                <a:solidFill>
+                  <a:srgbClr val="505050"/>
+                </a:solidFill>
+              </a:defRPr>
+            </a:pPr>
+            <a:r>
+              <a:t>Dataset: Heart Failure Prediction</a:t>
+            </a:r>
+          </a:p>
+          <a:p>
+            <a:pPr>
+              <a:spcAft>
+                <a:spcPts val="300"/>
+              </a:spcAft>
+            </a:pPr>
+          </a:p>
+          <a:p>
+            <a:pPr>
+              <a:spcBef>
+                <a:spcPts val="100"/>
+              </a:spcBef>
+              <a:defRPr b="1" sz="1300">
+                <a:solidFill>
+                  <a:srgbClr val="028090"/>
+                </a:solidFill>
+              </a:defRPr>
+            </a:pPr>
+            <a:r>
+              <a:t>Quality Metrics:</a:t>
+            </a:r>
+          </a:p>
+          <a:p>
+            <a:pPr>
+              <a:spcBef>
+                <a:spcPts val="100"/>
+              </a:spcBef>
+              <a:defRPr sz="1200">
+                <a:solidFill>
+                  <a:srgbClr val="505050"/>
+                </a:solidFill>
+              </a:defRPr>
+            </a:pPr>
+            <a:r>
+              <a:t>• Total Samples: 918 patient records</a:t>
+            </a:r>
+          </a:p>
+          <a:p>
+            <a:pPr>
+              <a:spcBef>
+                <a:spcPts val="100"/>
+              </a:spcBef>
+              <a:defRPr sz="1200">
+                <a:solidFill>
+                  <a:srgbClr val="505050"/>
+                </a:solidFill>
+              </a:defRPr>
+            </a:pPr>
+            <a:r>
+              <a:t>• Training Set: 734 samples (80%)</a:t>
+            </a:r>
+          </a:p>
+          <a:p>
+            <a:pPr>
+              <a:spcBef>
+                <a:spcPts val="100"/>
+              </a:spcBef>
+              <a:defRPr sz="1200">
+                <a:solidFill>
+                  <a:srgbClr val="505050"/>
+                </a:solidFill>
+              </a:defRPr>
+            </a:pPr>
+            <a:r>
+              <a:t>• Test Set: 184 samples (20%)</a:t>
+            </a:r>
+          </a:p>
+          <a:p>
+            <a:pPr>
+              <a:spcBef>
+                <a:spcPts val="100"/>
+              </a:spcBef>
+              <a:defRPr sz="1200">
+                <a:solidFill>
+                  <a:srgbClr val="505050"/>
+                </a:solidFill>
+              </a:defRPr>
+            </a:pPr>
+            <a:r>
+              <a:t>• Missing Values: 0</a:t>
+            </a:r>
+          </a:p>
+          <a:p>
+            <a:pPr>
+              <a:spcBef>
+                <a:spcPts val="100"/>
+              </a:spcBef>
+              <a:defRPr sz="1200">
+                <a:solidFill>
+                  <a:srgbClr val="505050"/>
+                </a:solidFill>
+              </a:defRPr>
+            </a:pPr>
+            <a:r>
+              <a:t>• Duplicate Rows: 0</a:t>
+            </a:r>
+          </a:p>
+          <a:p>
+            <a:pPr>
+              <a:spcAft>
+                <a:spcPts val="300"/>
+              </a:spcAft>
+            </a:pPr>
+          </a:p>
+          <a:p>
+            <a:pPr>
+              <a:spcBef>
+                <a:spcPts val="100"/>
+              </a:spcBef>
+              <a:defRPr b="1" sz="1300">
+                <a:solidFill>
+                  <a:srgbClr val="028090"/>
+                </a:solidFill>
+              </a:defRPr>
+            </a:pPr>
+            <a:r>
+              <a:t>11 Clinical Features:</a:t>
+            </a:r>
+          </a:p>
+          <a:p>
+            <a:pPr>
+              <a:spcBef>
+                <a:spcPts val="100"/>
+              </a:spcBef>
+              <a:defRPr sz="1200">
+                <a:solidFill>
+                  <a:srgbClr val="505050"/>
+                </a:solidFill>
+              </a:defRPr>
+            </a:pPr>
+            <a:r>
+              <a:t>Age, Sex, ChestPainType, RestingBP, Cholesterol</a:t>
+            </a:r>
+          </a:p>
+          <a:p>
+            <a:pPr>
+              <a:spcBef>
+                <a:spcPts val="100"/>
+              </a:spcBef>
+              <a:defRPr sz="1200">
+                <a:solidFill>
+                  <a:srgbClr val="505050"/>
+                </a:solidFill>
+              </a:defRPr>
+            </a:pPr>
+            <a:r>
+              <a:t>FastingBS, RestingECG, MaxHR, ExerciseAngina, Oldpeak, ST_Slope</a:t>
+            </a:r>
+          </a:p>
+          <a:p>
+            <a:pPr>
+              <a:spcAft>
+                <a:spcPts val="300"/>
+              </a:spcAft>
+            </a:pPr>
+          </a:p>
+          <a:p>
+            <a:pPr>
+              <a:spcBef>
+                <a:spcPts val="100"/>
+              </a:spcBef>
+              <a:defRPr sz="1200">
+                <a:solidFill>
+                  <a:srgbClr val="505050"/>
+                </a:solidFill>
+              </a:defRPr>
+            </a:pPr>
+            <a:r>
+              <a:t>Target: HeartDisease</a:t>
+            </a:r>
+          </a:p>
+          <a:p>
+            <a:pPr lvl="1">
+              <a:spcAft>
+                <a:spcPts val="100"/>
+              </a:spcAft>
+              <a:defRPr sz="1100">
+                <a:solidFill>
+                  <a:srgbClr val="505050"/>
+                </a:solidFill>
+              </a:defRPr>
+            </a:pPr>
+            <a:r>
+              <a:t>Binary - 55.3% vs 44.7%</a:t>
+            </a:r>
+          </a:p>
+        </p:txBody>
+      </p:sp>
+    </p:spTree>
+  </p:cSld>
+  <p:clrMapOvr>
+    <a:masterClrMapping/>
+  </p:clrMapOvr>
+</p:sld>
+</file>
+
+<file path=ppt/slides/slide5.xml><?xml version="1.0" encoding="utf-8"?>
+<p:sld xmlns:a="http://schemas.openxmlformats.org/drawingml/2006/main" xmlns:p="http://schemas.openxmlformats.org/presentationml/2006/main" xmlns:r="http://schemas.openxmlformats.org/officeDocument/2006/relationships">
+  <p:cSld>
+    <p:bg>
+      <p:bgPr>
+        <a:solidFill>
+          <a:srgbClr val="FFFFFF"/>
+        </a:solidFill>
+        <a:effectLst/>
+      </p:bgPr>
+    </p:bg>
+    <p:spTree>
+      <p:nvGrpSpPr>
+        <p:cNvPr id="1" name=""/>
+        <p:cNvGrpSpPr/>
+        <p:nvPr/>
+      </p:nvGrpSpPr>
+      <p:grpSpPr/>
+      <p:sp>
+        <p:nvSpPr>
+          <p:cNvPr id="2" name="Rectangle 1"/>
+          <p:cNvSpPr/>
+          <p:nvPr/>
+        </p:nvSpPr>
+        <p:spPr>
+          <a:xfrm>
+            <a:off x="0" y="0"/>
+            <a:ext cx="9144000" cy="914400"/>
+          </a:xfrm>
+          <a:prstGeom prst="rect">
+            <a:avLst/>
+          </a:prstGeom>
+          <a:solidFill>
+            <a:srgbClr val="065A82"/>
+          </a:solidFill>
+          <a:ln>
+            <a:solidFill>
+              <a:srgbClr val="065A82"/>
+            </a:solidFill>
+          </a:ln>
+        </p:spPr>
+        <p:style>
+          <a:lnRef idx="1">
+            <a:schemeClr val="accent1"/>
+          </a:lnRef>
+          <a:fillRef idx="3">
+            <a:schemeClr val="accent1"/>
+          </a:fillRef>
+          <a:effectRef idx="2">
+            <a:schemeClr val="accent1"/>
+          </a:effectRef>
+          <a:fontRef idx="minor">
+            <a:schemeClr val="lt1"/>
+          </a:fontRef>
+        </p:style>
+        <p:txBody>
+          <a:bodyPr rtlCol="0" anchor="ctr"/>
+          <a:lstStyle/>
+          <a:p>
+            <a:pPr algn="ctr"/>
+          </a:p>
+        </p:txBody>
+      </p:sp>
+      <p:sp>
+        <p:nvSpPr>
+          <p:cNvPr id="3" name="TextBox 2"/>
+          <p:cNvSpPr txBox="1"/>
+          <p:nvPr/>
+        </p:nvSpPr>
+        <p:spPr>
+          <a:xfrm>
+            <a:off x="457200" y="182880"/>
+            <a:ext cx="8229600" cy="731520"/>
+          </a:xfrm>
+          <a:prstGeom prst="rect">
+            <a:avLst/>
+          </a:prstGeom>
+          <a:noFill/>
+        </p:spPr>
+        <p:txBody>
+          <a:bodyPr wrap="none">
+            <a:spAutoFit/>
+          </a:bodyPr>
+          <a:lstStyle/>
+          <a:p>
+            <a:pPr>
+              <a:defRPr sz="4000" b="1">
+                <a:solidFill>
+                  <a:srgbClr val="FFFFFF"/>
+                </a:solidFill>
+              </a:defRPr>
+            </a:pPr>
+            <a:r>
+              <a:t>Exploratory Data Analysis - Part 1</a:t>
             </a:r>
           </a:p>
         </p:txBody>
       </p:sp>
       <p:pic>
         <p:nvPicPr>
-          <p:cNvPr id="4" name="Picture 3" descr="temp_eda1.png"/>
+          <p:cNvPr id="4" name="Picture 3" descr="eda1.png"/>
           <p:cNvPicPr>
             <a:picLocks noChangeAspect="1"/>
           </p:cNvPicPr>
@@ -6232,8 +5921,8 @@
         </p:blipFill>
         <p:spPr>
           <a:xfrm>
-            <a:off x="914400" y="1371600"/>
-            <a:ext cx="7315200" cy="3148314"/>
+            <a:off x="640080" y="1371600"/>
+            <a:ext cx="7863840" cy="3892114"/>
           </a:xfrm>
           <a:prstGeom prst="rect">
             <a:avLst/>
@@ -6341,14 +6030,14 @@
               </a:defRPr>
             </a:pPr>
             <a:r>
-              <a:t>Exploratory Data Analysis (EDA) - Part 2</a:t>
+              <a:t>Exploratory Data Analysis - Part 2</a:t>
             </a:r>
           </a:p>
         </p:txBody>
       </p:sp>
       <p:pic>
         <p:nvPicPr>
-          <p:cNvPr id="4" name="Picture 3" descr="temp_eda2.png"/>
+          <p:cNvPr id="4" name="Picture 3" descr="eda2.png"/>
           <p:cNvPicPr>
             <a:picLocks noChangeAspect="1"/>
           </p:cNvPicPr>
@@ -6362,8 +6051,8 @@
         </p:blipFill>
         <p:spPr>
           <a:xfrm>
-            <a:off x="731520" y="1188720"/>
-            <a:ext cx="7680960" cy="5736413"/>
+            <a:off x="640080" y="1371600"/>
+            <a:ext cx="7863840" cy="3990876"/>
           </a:xfrm>
           <a:prstGeom prst="rect">
             <a:avLst/>
@@ -6471,7 +6160,7 @@
               </a:defRPr>
             </a:pPr>
             <a:r>
-              <a:t>Machine Learning Models &amp; Preprocessing</a:t>
+              <a:t>ML &amp; Deep Learning Models Overview</a:t>
             </a:r>
           </a:p>
         </p:txBody>
@@ -6500,30 +6189,24 @@
           <a:p>
             <a:pPr>
               <a:spcBef>
-                <a:spcPts val="400"/>
-              </a:spcBef>
-              <a:spcAft>
-                <a:spcPts val="200"/>
-              </a:spcAft>
-              <a:defRPr sz="1500" b="1">
+                <a:spcPts val="100"/>
+              </a:spcBef>
+              <a:defRPr b="1" sz="1200">
                 <a:solidFill>
                   <a:srgbClr val="028090"/>
                 </a:solidFill>
               </a:defRPr>
             </a:pPr>
             <a:r>
-              <a:t>Models Evaluated:</a:t>
-            </a:r>
-          </a:p>
-          <a:p>
-            <a:pPr>
-              <a:spcBef>
-                <a:spcPts val="400"/>
-              </a:spcBef>
-              <a:spcAft>
-                <a:spcPts val="200"/>
-              </a:spcAft>
-              <a:defRPr sz="1300" b="1">
+              <a:t>Traditional ML (5 Models):</a:t>
+            </a:r>
+          </a:p>
+          <a:p>
+            <a:pPr>
+              <a:spcBef>
+                <a:spcPts val="100"/>
+              </a:spcBef>
+              <a:defRPr sz="1100">
                 <a:solidFill>
                   <a:srgbClr val="505050"/>
                 </a:solidFill>
@@ -6536,148 +6219,136 @@
           <a:p>
             <a:pPr lvl="1">
               <a:spcAft>
-                <a:spcPts val="200"/>
+                <a:spcPts val="100"/>
               </a:spcAft>
-              <a:defRPr sz="1200">
-                <a:solidFill>
-                  <a:srgbClr val="505050"/>
-                </a:solidFill>
-              </a:defRPr>
-            </a:pPr>
-            <a:r>
-              <a:t>Linear classification with L2 regularization</a:t>
-            </a:r>
-          </a:p>
-          <a:p>
-            <a:pPr>
-              <a:spcBef>
-                <a:spcPts val="400"/>
-              </a:spcBef>
-              <a:spcAft>
-                <a:spcPts val="200"/>
-              </a:spcAft>
-              <a:defRPr sz="1300" b="1">
-                <a:solidFill>
-                  <a:srgbClr val="505050"/>
-                </a:solidFill>
-              </a:defRPr>
-            </a:pPr>
-            <a:r>
-              <a:t>2. Support Vector Machine (Linear)</a:t>
+              <a:defRPr sz="1000">
+                <a:solidFill>
+                  <a:srgbClr val="505050"/>
+                </a:solidFill>
+              </a:defRPr>
+            </a:pPr>
+            <a:r>
+              <a:t>Linear classification</a:t>
+            </a:r>
+          </a:p>
+          <a:p>
+            <a:pPr>
+              <a:spcBef>
+                <a:spcPts val="100"/>
+              </a:spcBef>
+              <a:defRPr sz="1100">
+                <a:solidFill>
+                  <a:srgbClr val="505050"/>
+                </a:solidFill>
+              </a:defRPr>
+            </a:pPr>
+            <a:r>
+              <a:t>2. SVM Linear</a:t>
             </a:r>
           </a:p>
           <a:p>
             <a:pPr lvl="1">
               <a:spcAft>
-                <a:spcPts val="200"/>
+                <a:spcPts val="100"/>
               </a:spcAft>
-              <a:defRPr sz="1200">
-                <a:solidFill>
-                  <a:srgbClr val="505050"/>
-                </a:solidFill>
-              </a:defRPr>
-            </a:pPr>
-            <a:r>
-              <a:t>Linear kernel SVM for classification</a:t>
-            </a:r>
-          </a:p>
-          <a:p>
-            <a:pPr>
-              <a:spcBef>
-                <a:spcPts val="400"/>
-              </a:spcBef>
-              <a:spcAft>
-                <a:spcPts val="200"/>
-              </a:spcAft>
-              <a:defRPr sz="1300" b="1">
-                <a:solidFill>
-                  <a:srgbClr val="505050"/>
-                </a:solidFill>
-              </a:defRPr>
-            </a:pPr>
-            <a:r>
-              <a:t>3. Support Vector Machine (RBF)</a:t>
+              <a:defRPr sz="1000">
+                <a:solidFill>
+                  <a:srgbClr val="505050"/>
+                </a:solidFill>
+              </a:defRPr>
+            </a:pPr>
+            <a:r>
+              <a:t>Linear support vectors</a:t>
+            </a:r>
+          </a:p>
+          <a:p>
+            <a:pPr>
+              <a:spcBef>
+                <a:spcPts val="100"/>
+              </a:spcBef>
+              <a:defRPr sz="1100">
+                <a:solidFill>
+                  <a:srgbClr val="505050"/>
+                </a:solidFill>
+              </a:defRPr>
+            </a:pPr>
+            <a:r>
+              <a:t>3. SVM RBF</a:t>
             </a:r>
           </a:p>
           <a:p>
             <a:pPr lvl="1">
               <a:spcAft>
-                <a:spcPts val="200"/>
+                <a:spcPts val="100"/>
               </a:spcAft>
-              <a:defRPr sz="1200">
-                <a:solidFill>
-                  <a:srgbClr val="505050"/>
-                </a:solidFill>
-              </a:defRPr>
-            </a:pPr>
-            <a:r>
-              <a:t>Non-linear RBF kernel SVM</a:t>
-            </a:r>
-          </a:p>
-          <a:p>
-            <a:pPr>
-              <a:spcBef>
-                <a:spcPts val="400"/>
-              </a:spcBef>
-              <a:spcAft>
-                <a:spcPts val="200"/>
-              </a:spcAft>
-              <a:defRPr sz="1300" b="1">
-                <a:solidFill>
-                  <a:srgbClr val="505050"/>
-                </a:solidFill>
-              </a:defRPr>
-            </a:pPr>
-            <a:r>
-              <a:t>4. Random Forest</a:t>
+              <a:defRPr sz="1000">
+                <a:solidFill>
+                  <a:srgbClr val="505050"/>
+                </a:solidFill>
+              </a:defRPr>
+            </a:pPr>
+            <a:r>
+              <a:t>Non-linear kernels</a:t>
+            </a:r>
+          </a:p>
+          <a:p>
+            <a:pPr>
+              <a:spcBef>
+                <a:spcPts val="100"/>
+              </a:spcBef>
+              <a:defRPr sz="1100">
+                <a:solidFill>
+                  <a:srgbClr val="505050"/>
+                </a:solidFill>
+              </a:defRPr>
+            </a:pPr>
+            <a:r>
+              <a:t>4. Decision Tree</a:t>
             </a:r>
           </a:p>
           <a:p>
             <a:pPr lvl="1">
               <a:spcAft>
-                <a:spcPts val="200"/>
+                <a:spcPts val="100"/>
               </a:spcAft>
-              <a:defRPr sz="1200">
-                <a:solidFill>
-                  <a:srgbClr val="505050"/>
-                </a:solidFill>
-              </a:defRPr>
-            </a:pPr>
-            <a:r>
-              <a:t>Ensemble of 100 decision trees</a:t>
-            </a:r>
-          </a:p>
-          <a:p>
-            <a:pPr>
-              <a:spcBef>
-                <a:spcPts val="400"/>
-              </a:spcBef>
-              <a:spcAft>
-                <a:spcPts val="200"/>
-              </a:spcAft>
-              <a:defRPr sz="1300" b="1">
-                <a:solidFill>
-                  <a:srgbClr val="505050"/>
-                </a:solidFill>
-              </a:defRPr>
-            </a:pPr>
-            <a:r>
-              <a:t>5. Linear Discriminant Analysis</a:t>
+              <a:defRPr sz="1000">
+                <a:solidFill>
+                  <a:srgbClr val="505050"/>
+                </a:solidFill>
+              </a:defRPr>
+            </a:pPr>
+            <a:r>
+              <a:t>Tree-based rules</a:t>
+            </a:r>
+          </a:p>
+          <a:p>
+            <a:pPr>
+              <a:spcBef>
+                <a:spcPts val="100"/>
+              </a:spcBef>
+              <a:defRPr sz="1100">
+                <a:solidFill>
+                  <a:srgbClr val="505050"/>
+                </a:solidFill>
+              </a:defRPr>
+            </a:pPr>
+            <a:r>
+              <a:t>5. Random Forest</a:t>
             </a:r>
           </a:p>
           <a:p>
             <a:pPr lvl="1">
               <a:spcAft>
-                <a:spcPts val="200"/>
+                <a:spcPts val="100"/>
               </a:spcAft>
-              <a:defRPr sz="1200">
-                <a:solidFill>
-                  <a:srgbClr val="505050"/>
-                </a:solidFill>
-              </a:defRPr>
-            </a:pPr>
-            <a:r>
-              <a:t>Statistical linear classification method</a:t>
+              <a:defRPr sz="1000">
+                <a:solidFill>
+                  <a:srgbClr val="505050"/>
+                </a:solidFill>
+              </a:defRPr>
+            </a:pPr>
+            <a:r>
+              <a:t>Ensemble of 100 trees</a:t>
             </a:r>
           </a:p>
           <a:p>
@@ -6690,177 +6361,151 @@
           <a:p>
             <a:pPr>
               <a:spcBef>
-                <a:spcPts val="400"/>
-              </a:spcBef>
-              <a:spcAft>
-                <a:spcPts val="200"/>
-              </a:spcAft>
-              <a:defRPr sz="1500" b="1">
+                <a:spcPts val="100"/>
+              </a:spcBef>
+              <a:defRPr b="1" sz="1200">
                 <a:solidFill>
                   <a:srgbClr val="028090"/>
                 </a:solidFill>
               </a:defRPr>
             </a:pPr>
             <a:r>
-              <a:t>Preprocessing Steps:</a:t>
-            </a:r>
-          </a:p>
-          <a:p>
-            <a:pPr>
-              <a:spcBef>
-                <a:spcPts val="400"/>
-              </a:spcBef>
-              <a:spcAft>
-                <a:spcPts val="200"/>
-              </a:spcAft>
-              <a:defRPr sz="1200" b="0">
-                <a:solidFill>
-                  <a:srgbClr val="505050"/>
-                </a:solidFill>
-              </a:defRPr>
-            </a:pPr>
-            <a:r>
-              <a:t>• Categorical Encoding</a:t>
+              <a:t>Deep Learning:</a:t>
+            </a:r>
+          </a:p>
+          <a:p>
+            <a:pPr>
+              <a:spcBef>
+                <a:spcPts val="100"/>
+              </a:spcBef>
+              <a:defRPr sz="1100">
+                <a:solidFill>
+                  <a:srgbClr val="505050"/>
+                </a:solidFill>
+              </a:defRPr>
+            </a:pPr>
+            <a:r>
+              <a:t>Neural Network (TensorFlow/Keras)</a:t>
             </a:r>
           </a:p>
           <a:p>
             <a:pPr lvl="1">
               <a:spcAft>
-                <a:spcPts val="200"/>
+                <a:spcPts val="100"/>
               </a:spcAft>
-              <a:defRPr sz="1200">
-                <a:solidFill>
-                  <a:srgbClr val="505050"/>
-                </a:solidFill>
-              </a:defRPr>
-            </a:pPr>
-            <a:r>
-              <a:t>LabelEncoder for 5 categorical features</a:t>
-            </a:r>
-          </a:p>
-          <a:p>
-            <a:pPr>
-              <a:spcBef>
+              <a:defRPr sz="1000">
+                <a:solidFill>
+                  <a:srgbClr val="505050"/>
+                </a:solidFill>
+              </a:defRPr>
+            </a:pPr>
+            <a:r>
+              <a:t>3-layer feedforward</a:t>
+            </a:r>
+          </a:p>
+          <a:p>
+            <a:pPr>
+              <a:spcBef>
+                <a:spcPts val="100"/>
+              </a:spcBef>
+              <a:defRPr sz="1100">
+                <a:solidFill>
+                  <a:srgbClr val="505050"/>
+                </a:solidFill>
+              </a:defRPr>
+            </a:pPr>
+            <a:r>
+              <a:t>  128 -&gt; 64 -&gt; 32 neurons</a:t>
+            </a:r>
+          </a:p>
+          <a:p>
+            <a:pPr>
+              <a:spcBef>
+                <a:spcPts val="100"/>
+              </a:spcBef>
+              <a:defRPr sz="1100">
+                <a:solidFill>
+                  <a:srgbClr val="505050"/>
+                </a:solidFill>
+              </a:defRPr>
+            </a:pPr>
+            <a:r>
+              <a:t>  ReLU + Sigmoid activations</a:t>
+            </a:r>
+          </a:p>
+          <a:p>
+            <a:pPr>
+              <a:spcBef>
+                <a:spcPts val="100"/>
+              </a:spcBef>
+              <a:defRPr sz="1100">
+                <a:solidFill>
+                  <a:srgbClr val="505050"/>
+                </a:solidFill>
+              </a:defRPr>
+            </a:pPr>
+            <a:r>
+              <a:t>  Dropout (0.2-0.3) regularization</a:t>
+            </a:r>
+          </a:p>
+          <a:p>
+            <a:pPr>
+              <a:spcBef>
+                <a:spcPts val="100"/>
+              </a:spcBef>
+              <a:defRPr sz="1100">
+                <a:solidFill>
+                  <a:srgbClr val="505050"/>
+                </a:solidFill>
+              </a:defRPr>
+            </a:pPr>
+            <a:r>
+              <a:t>  100 epochs + Early Stopping</a:t>
+            </a:r>
+          </a:p>
+          <a:p>
+            <a:pPr>
+              <a:spcAft>
                 <a:spcPts val="400"/>
-              </a:spcBef>
-              <a:spcAft>
-                <a:spcPts val="200"/>
               </a:spcAft>
-              <a:defRPr sz="1200" b="0">
-                <a:solidFill>
-                  <a:srgbClr val="505050"/>
-                </a:solidFill>
-              </a:defRPr>
-            </a:pPr>
-            <a:r>
-              <a:t>• Feature Scaling</a:t>
-            </a:r>
-          </a:p>
-          <a:p>
-            <a:pPr lvl="1">
-              <a:spcAft>
-                <a:spcPts val="200"/>
-              </a:spcAft>
-              <a:defRPr sz="1200">
-                <a:solidFill>
-                  <a:srgbClr val="505050"/>
-                </a:solidFill>
-              </a:defRPr>
-            </a:pPr>
-            <a:r>
-              <a:t>StandardScaler for 6 numeric features</a:t>
-            </a:r>
-          </a:p>
-          <a:p>
-            <a:pPr>
-              <a:spcBef>
-                <a:spcPts val="400"/>
-              </a:spcBef>
-              <a:spcAft>
-                <a:spcPts val="200"/>
-              </a:spcAft>
-              <a:defRPr sz="1200" b="0">
-                <a:solidFill>
-                  <a:srgbClr val="505050"/>
-                </a:solidFill>
-              </a:defRPr>
-            </a:pPr>
-            <a:r>
-              <a:t>• Zero Handling</a:t>
-            </a:r>
-          </a:p>
-          <a:p>
-            <a:pPr lvl="1">
-              <a:spcAft>
-                <a:spcPts val="200"/>
-              </a:spcAft>
-              <a:defRPr sz="1200">
-                <a:solidFill>
-                  <a:srgbClr val="505050"/>
-                </a:solidFill>
-              </a:defRPr>
-            </a:pPr>
-            <a:r>
-              <a:t>Median imputation for Cholesterol &amp; RestingBP</a:t>
-            </a:r>
-          </a:p>
-          <a:p>
-            <a:pPr>
-              <a:spcBef>
-                <a:spcPts val="400"/>
-              </a:spcBef>
-              <a:spcAft>
-                <a:spcPts val="200"/>
-              </a:spcAft>
-              <a:defRPr sz="1200" b="0">
-                <a:solidFill>
-                  <a:srgbClr val="505050"/>
-                </a:solidFill>
-              </a:defRPr>
-            </a:pPr>
-            <a:r>
-              <a:t>• Data Splitting</a:t>
-            </a:r>
-          </a:p>
-          <a:p>
-            <a:pPr lvl="1">
-              <a:spcAft>
-                <a:spcPts val="200"/>
-              </a:spcAft>
-              <a:defRPr sz="1200">
-                <a:solidFill>
-                  <a:srgbClr val="505050"/>
-                </a:solidFill>
-              </a:defRPr>
-            </a:pPr>
-            <a:r>
-              <a:t>80/20 stratified train-test split</a:t>
-            </a:r>
-          </a:p>
-          <a:p>
-            <a:pPr>
-              <a:spcBef>
-                <a:spcPts val="400"/>
-              </a:spcBef>
-              <a:spcAft>
-                <a:spcPts val="200"/>
-              </a:spcAft>
-              <a:defRPr sz="1200" b="0">
-                <a:solidFill>
-                  <a:srgbClr val="505050"/>
-                </a:solidFill>
-              </a:defRPr>
-            </a:pPr>
-            <a:r>
-              <a:t>• Cross-Validation</a:t>
-            </a:r>
-          </a:p>
-          <a:p>
-            <a:pPr lvl="1">
-              <a:spcAft>
-                <a:spcPts val="200"/>
-              </a:spcAft>
-              <a:defRPr sz="1200">
+            </a:pPr>
+          </a:p>
+          <a:p>
+            <a:pPr>
+              <a:spcBef>
+                <a:spcPts val="100"/>
+              </a:spcBef>
+              <a:defRPr b="1" sz="1200">
+                <a:solidFill>
+                  <a:srgbClr val="028090"/>
+                </a:solidFill>
+              </a:defRPr>
+            </a:pPr>
+            <a:r>
+              <a:t>Preprocessing:</a:t>
+            </a:r>
+          </a:p>
+          <a:p>
+            <a:pPr>
+              <a:spcBef>
+                <a:spcPts val="100"/>
+              </a:spcBef>
+              <a:defRPr sz="1100">
+                <a:solidFill>
+                  <a:srgbClr val="505050"/>
+                </a:solidFill>
+              </a:defRPr>
+            </a:pPr>
+            <a:r>
+              <a:t>LabelEncoder + StandardScaler</a:t>
+            </a:r>
+          </a:p>
+          <a:p>
+            <a:pPr>
+              <a:spcBef>
+                <a:spcPts val="100"/>
+              </a:spcBef>
+              <a:defRPr sz="1100">
                 <a:solidFill>
                   <a:srgbClr val="505050"/>
                 </a:solidFill>
@@ -6980,7 +6625,7 @@
       </p:sp>
       <p:pic>
         <p:nvPicPr>
-          <p:cNvPr id="4" name="Picture 3" descr="temp_feature_importance.png"/>
+          <p:cNvPr id="4" name="Picture 3" descr="fi.png"/>
           <p:cNvPicPr>
             <a:picLocks noChangeAspect="1"/>
           </p:cNvPicPr>
@@ -7103,14 +6748,14 @@
               </a:defRPr>
             </a:pPr>
             <a:r>
-              <a:t>Model Performance Metrics</a:t>
+              <a:t>All Models Performance Comparison</a:t>
             </a:r>
           </a:p>
         </p:txBody>
       </p:sp>
       <p:pic>
         <p:nvPicPr>
-          <p:cNvPr id="4" name="Picture 3" descr="temp_metrics.png"/>
+          <p:cNvPr id="4" name="Picture 3" descr="models.png"/>
           <p:cNvPicPr>
             <a:picLocks noChangeAspect="1"/>
           </p:cNvPicPr>
@@ -7124,8 +6769,8 @@
         </p:blipFill>
         <p:spPr>
           <a:xfrm>
-            <a:off x="914400" y="1828800"/>
-            <a:ext cx="7315200" cy="3611301"/>
+            <a:off x="182880" y="1371600"/>
+            <a:ext cx="8778240" cy="3664611"/>
           </a:xfrm>
           <a:prstGeom prst="rect">
             <a:avLst/>

</xml_diff>